<commit_message>
Add JavaScript async examples and refactor callback hell to promises
</commit_message>
<xml_diff>
--- a/material/4_WEB/03_Javascript(2).pptx
+++ b/material/4_WEB/03_Javascript(2).pptx
@@ -57,9 +57,9 @@
     <p:sldId id="491" r:id="rId48"/>
     <p:sldId id="283" r:id="rId49"/>
     <p:sldId id="272" r:id="rId50"/>
-    <p:sldId id="499" r:id="rId51"/>
-    <p:sldId id="500" r:id="rId52"/>
-    <p:sldId id="501" r:id="rId53"/>
+    <p:sldId id="492" r:id="rId51"/>
+    <p:sldId id="493" r:id="rId52"/>
+    <p:sldId id="494" r:id="rId53"/>
     <p:sldId id="813" r:id="rId54"/>
   </p:sldIdLst>
   <p:sldSz cx="12192000" cy="6858000"/>
@@ -270,7 +270,7 @@
             <a:fld id="{A13A867C-D490-40C2-AB8D-A60FA70A9BF5}" type="datetimeFigureOut">
               <a:rPr lang="ko-KR" altLang="en-US" smtClean="0"/>
               <a:pPr/>
-              <a:t>2026-01-06</a:t>
+              <a:t>2026-02-02</a:t>
             </a:fld>
             <a:endParaRPr lang="ko-KR" altLang="en-US" dirty="0"/>
           </a:p>
@@ -4168,7 +4168,7 @@
           <a:bodyPr/>
           <a:lstStyle/>
           <a:p>
-            <a:endParaRPr lang="en-US" altLang="ko-KR" dirty="0"/>
+            <a:endParaRPr lang="ko-KR" altLang="en-US" dirty="0"/>
           </a:p>
         </p:txBody>
       </p:sp>
@@ -4187,7 +4187,7 @@
           <a:bodyPr/>
           <a:lstStyle/>
           <a:p>
-            <a:fld id="{C09E5BFC-1559-42F1-8940-AB342D56BF02}" type="slidenum">
+            <a:fld id="{3C2E56F0-CD7D-4DA1-A04D-36AB1B7850CF}" type="slidenum">
               <a:rPr lang="ko-KR" altLang="en-US" smtClean="0"/>
               <a:t>50</a:t>
             </a:fld>
@@ -4198,7 +4198,7 @@
     </p:spTree>
     <p:extLst>
       <p:ext uri="{BB962C8B-B14F-4D97-AF65-F5344CB8AC3E}">
-        <p14:creationId xmlns:p14="http://schemas.microsoft.com/office/powerpoint/2010/main" val="2691871518"/>
+        <p14:creationId xmlns:p14="http://schemas.microsoft.com/office/powerpoint/2010/main" val="916006974"/>
       </p:ext>
     </p:extLst>
   </p:cSld>
@@ -4252,7 +4252,7 @@
           <a:bodyPr/>
           <a:lstStyle/>
           <a:p>
-            <a:endParaRPr lang="en-US" altLang="ko-KR" dirty="0"/>
+            <a:endParaRPr lang="ko-KR" altLang="en-US" dirty="0"/>
           </a:p>
         </p:txBody>
       </p:sp>
@@ -4271,7 +4271,7 @@
           <a:bodyPr/>
           <a:lstStyle/>
           <a:p>
-            <a:fld id="{C09E5BFC-1559-42F1-8940-AB342D56BF02}" type="slidenum">
+            <a:fld id="{3C2E56F0-CD7D-4DA1-A04D-36AB1B7850CF}" type="slidenum">
               <a:rPr lang="ko-KR" altLang="en-US" smtClean="0"/>
               <a:t>51</a:t>
             </a:fld>
@@ -4282,7 +4282,7 @@
     </p:spTree>
     <p:extLst>
       <p:ext uri="{BB962C8B-B14F-4D97-AF65-F5344CB8AC3E}">
-        <p14:creationId xmlns:p14="http://schemas.microsoft.com/office/powerpoint/2010/main" val="309875304"/>
+        <p14:creationId xmlns:p14="http://schemas.microsoft.com/office/powerpoint/2010/main" val="1028784904"/>
       </p:ext>
     </p:extLst>
   </p:cSld>
@@ -4336,7 +4336,7 @@
           <a:bodyPr/>
           <a:lstStyle/>
           <a:p>
-            <a:endParaRPr lang="en-US" altLang="ko-KR" dirty="0"/>
+            <a:endParaRPr lang="ko-KR" altLang="en-US" dirty="0"/>
           </a:p>
         </p:txBody>
       </p:sp>
@@ -4355,7 +4355,7 @@
           <a:bodyPr/>
           <a:lstStyle/>
           <a:p>
-            <a:fld id="{C09E5BFC-1559-42F1-8940-AB342D56BF02}" type="slidenum">
+            <a:fld id="{3C2E56F0-CD7D-4DA1-A04D-36AB1B7850CF}" type="slidenum">
               <a:rPr lang="ko-KR" altLang="en-US" smtClean="0"/>
               <a:t>52</a:t>
             </a:fld>
@@ -4366,7 +4366,7 @@
     </p:spTree>
     <p:extLst>
       <p:ext uri="{BB962C8B-B14F-4D97-AF65-F5344CB8AC3E}">
-        <p14:creationId xmlns:p14="http://schemas.microsoft.com/office/powerpoint/2010/main" val="3006849278"/>
+        <p14:creationId xmlns:p14="http://schemas.microsoft.com/office/powerpoint/2010/main" val="3453958198"/>
       </p:ext>
     </p:extLst>
   </p:cSld>
@@ -5210,7 +5210,7 @@
           <a:p>
             <a:fld id="{442BEE3F-2E9A-4FD8-8B8A-8619F3E161C0}" type="datetime1">
               <a:rPr lang="ko-KR" altLang="en-US" smtClean="0"/>
-              <a:t>2026-01-06</a:t>
+              <a:t>2026-02-02</a:t>
             </a:fld>
             <a:endParaRPr lang="ko-KR" altLang="en-US"/>
           </a:p>
@@ -5497,7 +5497,7 @@
           <a:p>
             <a:fld id="{0F78D9C4-20C1-4B15-A116-16DC77AD9A1E}" type="datetime1">
               <a:rPr lang="ko-KR" altLang="en-US" smtClean="0"/>
-              <a:t>2026-01-06</a:t>
+              <a:t>2026-02-02</a:t>
             </a:fld>
             <a:endParaRPr lang="ko-KR" altLang="en-US"/>
           </a:p>
@@ -5672,7 +5672,7 @@
           <a:p>
             <a:fld id="{7F5E23C3-0E3D-4E4E-8486-D7FB4C073DC1}" type="datetime1">
               <a:rPr lang="ko-KR" altLang="en-US" smtClean="0"/>
-              <a:t>2026-01-06</a:t>
+              <a:t>2026-02-02</a:t>
             </a:fld>
             <a:endParaRPr lang="ko-KR" altLang="en-US"/>
           </a:p>
@@ -5785,7 +5785,7 @@
           <a:p>
             <a:fld id="{0E19CB95-6D28-40F1-9DA3-1BAC5D4B5B4F}" type="datetime6">
               <a:rPr lang="ko-KR" altLang="en-US" smtClean="0"/>
-              <a:t>2026년 1월</a:t>
+              <a:t>2026년 2월</a:t>
             </a:fld>
             <a:endParaRPr lang="ko-KR" altLang="en-US"/>
           </a:p>
@@ -6206,7 +6206,7 @@
           <a:p>
             <a:fld id="{7F5E23C3-0E3D-4E4E-8486-D7FB4C073DC1}" type="datetime1">
               <a:rPr lang="ko-KR" altLang="en-US" smtClean="0"/>
-              <a:t>2026-01-06</a:t>
+              <a:t>2026-02-02</a:t>
             </a:fld>
             <a:endParaRPr lang="ko-KR" altLang="en-US"/>
           </a:p>
@@ -7169,7 +7169,7 @@
           <a:p>
             <a:fld id="{0F78D9C4-20C1-4B15-A116-16DC77AD9A1E}" type="datetime1">
               <a:rPr lang="ko-KR" altLang="en-US" smtClean="0"/>
-              <a:t>2026-01-06</a:t>
+              <a:t>2026-02-02</a:t>
             </a:fld>
             <a:endParaRPr lang="ko-KR" altLang="en-US"/>
           </a:p>
@@ -7345,7 +7345,7 @@
           <a:p>
             <a:fld id="{0E19CB95-6D28-40F1-9DA3-1BAC5D4B5B4F}" type="datetime6">
               <a:rPr lang="ko-KR" altLang="en-US" smtClean="0"/>
-              <a:t>2026년 1월</a:t>
+              <a:t>2026년 2월</a:t>
             </a:fld>
             <a:endParaRPr lang="ko-KR" altLang="en-US"/>
           </a:p>
@@ -7902,7 +7902,7 @@
           <a:p>
             <a:fld id="{0F78D9C4-20C1-4B15-A116-16DC77AD9A1E}" type="datetime1">
               <a:rPr lang="ko-KR" altLang="en-US" smtClean="0"/>
-              <a:t>2026-01-06</a:t>
+              <a:t>2026-02-02</a:t>
             </a:fld>
             <a:endParaRPr lang="ko-KR" altLang="en-US"/>
           </a:p>
@@ -9183,7 +9183,7 @@
           <a:p>
             <a:fld id="{0F78D9C4-20C1-4B15-A116-16DC77AD9A1E}" type="datetime1">
               <a:rPr lang="ko-KR" altLang="en-US" smtClean="0"/>
-              <a:t>2026-01-06</a:t>
+              <a:t>2026-02-02</a:t>
             </a:fld>
             <a:endParaRPr lang="ko-KR" altLang="en-US"/>
           </a:p>
@@ -9625,7 +9625,7 @@
           <a:p>
             <a:fld id="{0F78D9C4-20C1-4B15-A116-16DC77AD9A1E}" type="datetime1">
               <a:rPr lang="ko-KR" altLang="en-US" smtClean="0"/>
-              <a:t>2026-01-06</a:t>
+              <a:t>2026-02-02</a:t>
             </a:fld>
             <a:endParaRPr lang="ko-KR" altLang="en-US"/>
           </a:p>
@@ -9783,7 +9783,7 @@
           <a:p>
             <a:fld id="{0F78D9C4-20C1-4B15-A116-16DC77AD9A1E}" type="datetime1">
               <a:rPr lang="ko-KR" altLang="en-US" smtClean="0"/>
-              <a:t>2026-01-06</a:t>
+              <a:t>2026-02-02</a:t>
             </a:fld>
             <a:endParaRPr lang="ko-KR" altLang="en-US"/>
           </a:p>
@@ -9868,10 +9868,10 @@
       </p:sp>
       <p:sp>
         <p:nvSpPr>
-          <p:cNvPr id="6" name="내용 개체 틀 1">
+          <p:cNvPr id="3" name="내용 개체 틀 1">
             <a:extLst>
               <a:ext uri="{FF2B5EF4-FFF2-40B4-BE49-F238E27FC236}">
-                <a16:creationId xmlns:a16="http://schemas.microsoft.com/office/drawing/2014/main" id="{70C2BA37-BE91-39C4-AC08-0E8A1052E2F7}"/>
+                <a16:creationId xmlns:a16="http://schemas.microsoft.com/office/drawing/2014/main" id="{07A38127-3A5D-0497-41F4-F4B1870C9690}"/>
               </a:ext>
             </a:extLst>
           </p:cNvPr>
@@ -9882,39 +9882,39 @@
         </p:nvSpPr>
         <p:spPr>
           <a:xfrm>
-            <a:off x="838200" y="1825625"/>
-            <a:ext cx="10515600" cy="4351338"/>
+            <a:off x="251787" y="1511166"/>
+            <a:ext cx="11701221" cy="4665797"/>
           </a:xfrm>
           <a:prstGeom prst="rect">
             <a:avLst/>
           </a:prstGeom>
         </p:spPr>
         <p:txBody>
-          <a:bodyPr vert="horz" lIns="91440" tIns="45720" rIns="91440" bIns="45720" rtlCol="0">
+          <a:bodyPr vert="horz" lIns="90000" tIns="45720" rIns="90000" bIns="45720" rtlCol="0">
             <a:normAutofit/>
           </a:bodyPr>
           <a:lstStyle>
             <a:lvl1pPr marL="228600" indent="-228600" algn="l" defTabSz="914400" rtl="0" eaLnBrk="1" latinLnBrk="1" hangingPunct="1">
               <a:lnSpc>
-                <a:spcPct val="90000"/>
+                <a:spcPct val="120000"/>
               </a:lnSpc>
               <a:spcBef>
                 <a:spcPts val="1000"/>
               </a:spcBef>
-              <a:buFont typeface="Arial" panose="020B0604020202020204" pitchFamily="34" charset="0"/>
-              <a:buChar char="•"/>
+              <a:buFont typeface="Wingdings" panose="05000000000000000000" pitchFamily="2" charset="2"/>
+              <a:buChar char="§"/>
               <a:defRPr sz="2800" kern="1200">
                 <a:solidFill>
                   <a:schemeClr val="tx1"/>
                 </a:solidFill>
-                <a:latin typeface="+mn-lt"/>
-                <a:ea typeface="+mn-ea"/>
-                <a:cs typeface="+mn-cs"/>
+                <a:latin typeface="Pretendard Medium" panose="02000603000000020004" pitchFamily="2" charset="-127"/>
+                <a:ea typeface="Pretendard Medium" panose="02000603000000020004" pitchFamily="2" charset="-127"/>
+                <a:cs typeface="Pretendard Medium" panose="02000603000000020004" pitchFamily="2" charset="-127"/>
               </a:defRPr>
             </a:lvl1pPr>
             <a:lvl2pPr marL="685800" indent="-228600" algn="l" defTabSz="914400" rtl="0" eaLnBrk="1" latinLnBrk="1" hangingPunct="1">
               <a:lnSpc>
-                <a:spcPct val="90000"/>
+                <a:spcPct val="120000"/>
               </a:lnSpc>
               <a:spcBef>
                 <a:spcPts val="500"/>
@@ -9925,14 +9925,14 @@
                 <a:solidFill>
                   <a:schemeClr val="tx1"/>
                 </a:solidFill>
-                <a:latin typeface="+mn-lt"/>
-                <a:ea typeface="+mn-ea"/>
-                <a:cs typeface="+mn-cs"/>
+                <a:latin typeface="Pretendard Light" panose="02000403000000020004" pitchFamily="2" charset="-127"/>
+                <a:ea typeface="Pretendard Light" panose="02000403000000020004" pitchFamily="2" charset="-127"/>
+                <a:cs typeface="Pretendard Light" panose="02000403000000020004" pitchFamily="2" charset="-127"/>
               </a:defRPr>
             </a:lvl2pPr>
             <a:lvl3pPr marL="1143000" indent="-228600" algn="l" defTabSz="914400" rtl="0" eaLnBrk="1" latinLnBrk="1" hangingPunct="1">
               <a:lnSpc>
-                <a:spcPct val="90000"/>
+                <a:spcPct val="120000"/>
               </a:lnSpc>
               <a:spcBef>
                 <a:spcPts val="500"/>
@@ -9943,14 +9943,14 @@
                 <a:solidFill>
                   <a:schemeClr val="tx1"/>
                 </a:solidFill>
-                <a:latin typeface="+mn-lt"/>
-                <a:ea typeface="+mn-ea"/>
-                <a:cs typeface="+mn-cs"/>
+                <a:latin typeface="Pretendard Light" panose="02000403000000020004" pitchFamily="2" charset="-127"/>
+                <a:ea typeface="Pretendard Light" panose="02000403000000020004" pitchFamily="2" charset="-127"/>
+                <a:cs typeface="Pretendard Light" panose="02000403000000020004" pitchFamily="2" charset="-127"/>
               </a:defRPr>
             </a:lvl3pPr>
             <a:lvl4pPr marL="1600200" indent="-228600" algn="l" defTabSz="914400" rtl="0" eaLnBrk="1" latinLnBrk="1" hangingPunct="1">
               <a:lnSpc>
-                <a:spcPct val="90000"/>
+                <a:spcPct val="120000"/>
               </a:lnSpc>
               <a:spcBef>
                 <a:spcPts val="500"/>
@@ -9961,14 +9961,14 @@
                 <a:solidFill>
                   <a:schemeClr val="tx1"/>
                 </a:solidFill>
-                <a:latin typeface="+mn-lt"/>
-                <a:ea typeface="+mn-ea"/>
-                <a:cs typeface="+mn-cs"/>
+                <a:latin typeface="Pretendard Light" panose="02000403000000020004" pitchFamily="2" charset="-127"/>
+                <a:ea typeface="Pretendard Light" panose="02000403000000020004" pitchFamily="2" charset="-127"/>
+                <a:cs typeface="Pretendard Light" panose="02000403000000020004" pitchFamily="2" charset="-127"/>
               </a:defRPr>
             </a:lvl4pPr>
             <a:lvl5pPr marL="2057400" indent="-228600" algn="l" defTabSz="914400" rtl="0" eaLnBrk="1" latinLnBrk="1" hangingPunct="1">
               <a:lnSpc>
-                <a:spcPct val="90000"/>
+                <a:spcPct val="120000"/>
               </a:lnSpc>
               <a:spcBef>
                 <a:spcPts val="500"/>
@@ -9979,9 +9979,9 @@
                 <a:solidFill>
                   <a:schemeClr val="tx1"/>
                 </a:solidFill>
-                <a:latin typeface="+mn-lt"/>
-                <a:ea typeface="+mn-ea"/>
-                <a:cs typeface="+mn-cs"/>
+                <a:latin typeface="Pretendard Light" panose="02000403000000020004" pitchFamily="2" charset="-127"/>
+                <a:ea typeface="Pretendard Light" panose="02000403000000020004" pitchFamily="2" charset="-127"/>
+                <a:cs typeface="Pretendard Light" panose="02000403000000020004" pitchFamily="2" charset="-127"/>
               </a:defRPr>
             </a:lvl5pPr>
             <a:lvl6pPr marL="2514600" indent="-228600" algn="l" defTabSz="914400" rtl="0" eaLnBrk="1" latinLnBrk="1" hangingPunct="1">
@@ -10058,218 +10058,266 @@
             </a:lvl9pPr>
           </a:lstStyle>
           <a:p>
-            <a:pPr marL="457200" lvl="1" indent="0">
-              <a:buFont typeface="Arial" panose="020B0604020202020204" pitchFamily="34" charset="0"/>
-              <a:buNone/>
-            </a:pPr>
-            <a:endParaRPr lang="en-US" altLang="ko-KR" dirty="0">
+            <a:r>
+              <a:rPr lang="en-US" altLang="ko-KR" dirty="0"/>
+              <a:t>const word1 = “</a:t>
+            </a:r>
+            <a:r>
+              <a:rPr lang="en-US" altLang="ko-KR" dirty="0" err="1"/>
+              <a:t>abc</a:t>
+            </a:r>
+            <a:r>
+              <a:rPr lang="en-US" altLang="ko-KR" dirty="0"/>
+              <a:t>”;</a:t>
+            </a:r>
+            <a:br>
+              <a:rPr lang="en-US" altLang="ko-KR" dirty="0"/>
+            </a:br>
+            <a:r>
+              <a:rPr lang="en-US" altLang="ko-KR" dirty="0"/>
+              <a:t>const word2 = “</a:t>
+            </a:r>
+            <a:r>
+              <a:rPr lang="en-US" altLang="ko-KR" dirty="0" err="1"/>
+              <a:t>xyz</a:t>
+            </a:r>
+            <a:r>
+              <a:rPr lang="en-US" altLang="ko-KR" dirty="0"/>
+              <a:t>”;</a:t>
+            </a:r>
+            <a:br>
+              <a:rPr lang="en-US" altLang="ko-KR" dirty="0"/>
+            </a:br>
+            <a:r>
+              <a:rPr lang="ko-KR" altLang="en-US" dirty="0"/>
+              <a:t>로 선언</a:t>
+            </a:r>
+            <a:endParaRPr lang="en-US" altLang="ko-KR" dirty="0"/>
+          </a:p>
+          <a:p>
+            <a:endParaRPr lang="en-US" altLang="ko-KR" dirty="0"/>
+          </a:p>
+          <a:p>
+            <a:r>
+              <a:rPr lang="ko-KR" altLang="en-US" dirty="0"/>
+              <a:t>두 개의 문자열을 합쳐서 배열로 만들기</a:t>
+            </a:r>
+            <a:endParaRPr lang="en-US" altLang="ko-KR" dirty="0"/>
+          </a:p>
+          <a:p>
+            <a:r>
+              <a:rPr lang="ko-KR" altLang="en-US" dirty="0"/>
+              <a:t>결과물</a:t>
+            </a:r>
+          </a:p>
+          <a:p>
+            <a:endParaRPr lang="ko-KR" altLang="en-US" dirty="0"/>
+          </a:p>
+        </p:txBody>
+      </p:sp>
+      <p:sp>
+        <p:nvSpPr>
+          <p:cNvPr id="7" name="TextBox 6">
+            <a:extLst>
+              <a:ext uri="{FF2B5EF4-FFF2-40B4-BE49-F238E27FC236}">
+                <a16:creationId xmlns:a16="http://schemas.microsoft.com/office/drawing/2014/main" id="{893296E8-4EDB-A516-39AF-FD2A7075A5A4}"/>
+              </a:ext>
+            </a:extLst>
+          </p:cNvPr>
+          <p:cNvSpPr txBox="1"/>
+          <p:nvPr/>
+        </p:nvSpPr>
+        <p:spPr>
+          <a:xfrm>
+            <a:off x="1942734" y="4542390"/>
+            <a:ext cx="4508119" cy="461665"/>
+          </a:xfrm>
+          <a:prstGeom prst="rect">
+            <a:avLst/>
+          </a:prstGeom>
+          <a:solidFill>
+            <a:srgbClr val="002060"/>
+          </a:solidFill>
+        </p:spPr>
+        <p:txBody>
+          <a:bodyPr wrap="square">
+            <a:spAutoFit/>
+          </a:bodyPr>
+          <a:lstStyle/>
+          <a:p>
+            <a:r>
+              <a:rPr lang="en-US" altLang="ko-KR" sz="2400" b="0" dirty="0">
+                <a:solidFill>
+                  <a:srgbClr val="9ABDF5"/>
+                </a:solidFill>
+                <a:effectLst/>
+                <a:latin typeface="Consolas" panose="020B0609020204030204" pitchFamily="49" charset="0"/>
+                <a:ea typeface="Pretendard Variable Medium" panose="02000003000000020004" pitchFamily="2" charset="-127"/>
+              </a:rPr>
+              <a:t>[</a:t>
+            </a:r>
+            <a:r>
+              <a:rPr lang="en-US" altLang="ko-KR" sz="2400" b="0" dirty="0">
+                <a:solidFill>
+                  <a:srgbClr val="89DDFF"/>
+                </a:solidFill>
+                <a:effectLst/>
+                <a:latin typeface="Consolas" panose="020B0609020204030204" pitchFamily="49" charset="0"/>
+                <a:ea typeface="Pretendard Variable Medium" panose="02000003000000020004" pitchFamily="2" charset="-127"/>
+              </a:rPr>
+              <a:t>"</a:t>
+            </a:r>
+            <a:r>
+              <a:rPr lang="en-US" altLang="ko-KR" sz="2400" b="0" dirty="0" err="1">
+                <a:solidFill>
+                  <a:srgbClr val="9ECE6A"/>
+                </a:solidFill>
+                <a:effectLst/>
+                <a:latin typeface="Consolas" panose="020B0609020204030204" pitchFamily="49" charset="0"/>
+                <a:ea typeface="Pretendard Variable Medium" panose="02000003000000020004" pitchFamily="2" charset="-127"/>
+              </a:rPr>
+              <a:t>a</a:t>
+            </a:r>
+            <a:r>
+              <a:rPr lang="en-US" altLang="ko-KR" sz="2400" b="0" dirty="0" err="1">
+                <a:solidFill>
+                  <a:srgbClr val="89DDFF"/>
+                </a:solidFill>
+                <a:effectLst/>
+                <a:latin typeface="Consolas" panose="020B0609020204030204" pitchFamily="49" charset="0"/>
+                <a:ea typeface="Pretendard Variable Medium" panose="02000003000000020004" pitchFamily="2" charset="-127"/>
+              </a:rPr>
+              <a:t>","</a:t>
+            </a:r>
+            <a:r>
+              <a:rPr lang="en-US" altLang="ko-KR" sz="2400" b="0" dirty="0" err="1">
+                <a:solidFill>
+                  <a:srgbClr val="9ECE6A"/>
+                </a:solidFill>
+                <a:effectLst/>
+                <a:latin typeface="Consolas" panose="020B0609020204030204" pitchFamily="49" charset="0"/>
+                <a:ea typeface="Pretendard Variable Medium" panose="02000003000000020004" pitchFamily="2" charset="-127"/>
+              </a:rPr>
+              <a:t>b</a:t>
+            </a:r>
+            <a:r>
+              <a:rPr lang="en-US" altLang="ko-KR" sz="2400" b="0" dirty="0" err="1">
+                <a:solidFill>
+                  <a:srgbClr val="89DDFF"/>
+                </a:solidFill>
+                <a:effectLst/>
+                <a:latin typeface="Consolas" panose="020B0609020204030204" pitchFamily="49" charset="0"/>
+                <a:ea typeface="Pretendard Variable Medium" panose="02000003000000020004" pitchFamily="2" charset="-127"/>
+              </a:rPr>
+              <a:t>","</a:t>
+            </a:r>
+            <a:r>
+              <a:rPr lang="en-US" altLang="ko-KR" sz="2400" b="0" dirty="0" err="1">
+                <a:solidFill>
+                  <a:srgbClr val="9ECE6A"/>
+                </a:solidFill>
+                <a:effectLst/>
+                <a:latin typeface="Consolas" panose="020B0609020204030204" pitchFamily="49" charset="0"/>
+                <a:ea typeface="Pretendard Variable Medium" panose="02000003000000020004" pitchFamily="2" charset="-127"/>
+              </a:rPr>
+              <a:t>c</a:t>
+            </a:r>
+            <a:r>
+              <a:rPr lang="en-US" altLang="ko-KR" sz="2400" b="0" dirty="0" err="1">
+                <a:solidFill>
+                  <a:srgbClr val="89DDFF"/>
+                </a:solidFill>
+                <a:effectLst/>
+                <a:latin typeface="Consolas" panose="020B0609020204030204" pitchFamily="49" charset="0"/>
+                <a:ea typeface="Pretendard Variable Medium" panose="02000003000000020004" pitchFamily="2" charset="-127"/>
+              </a:rPr>
+              <a:t>","</a:t>
+            </a:r>
+            <a:r>
+              <a:rPr lang="en-US" altLang="ko-KR" sz="2400" b="0" dirty="0" err="1">
+                <a:solidFill>
+                  <a:srgbClr val="9ECE6A"/>
+                </a:solidFill>
+                <a:effectLst/>
+                <a:latin typeface="Consolas" panose="020B0609020204030204" pitchFamily="49" charset="0"/>
+                <a:ea typeface="Pretendard Variable Medium" panose="02000003000000020004" pitchFamily="2" charset="-127"/>
+              </a:rPr>
+              <a:t>x</a:t>
+            </a:r>
+            <a:r>
+              <a:rPr lang="en-US" altLang="ko-KR" sz="2400" b="0" dirty="0" err="1">
+                <a:solidFill>
+                  <a:srgbClr val="89DDFF"/>
+                </a:solidFill>
+                <a:effectLst/>
+                <a:latin typeface="Consolas" panose="020B0609020204030204" pitchFamily="49" charset="0"/>
+                <a:ea typeface="Pretendard Variable Medium" panose="02000003000000020004" pitchFamily="2" charset="-127"/>
+              </a:rPr>
+              <a:t>","</a:t>
+            </a:r>
+            <a:r>
+              <a:rPr lang="en-US" altLang="ko-KR" sz="2400" b="0" dirty="0" err="1">
+                <a:solidFill>
+                  <a:srgbClr val="9ECE6A"/>
+                </a:solidFill>
+                <a:effectLst/>
+                <a:latin typeface="Consolas" panose="020B0609020204030204" pitchFamily="49" charset="0"/>
+                <a:ea typeface="Pretendard Variable Medium" panose="02000003000000020004" pitchFamily="2" charset="-127"/>
+              </a:rPr>
+              <a:t>y</a:t>
+            </a:r>
+            <a:r>
+              <a:rPr lang="en-US" altLang="ko-KR" sz="2400" b="0" dirty="0" err="1">
+                <a:solidFill>
+                  <a:srgbClr val="89DDFF"/>
+                </a:solidFill>
+                <a:effectLst/>
+                <a:latin typeface="Consolas" panose="020B0609020204030204" pitchFamily="49" charset="0"/>
+                <a:ea typeface="Pretendard Variable Medium" panose="02000003000000020004" pitchFamily="2" charset="-127"/>
+              </a:rPr>
+              <a:t>","</a:t>
+            </a:r>
+            <a:r>
+              <a:rPr lang="en-US" altLang="ko-KR" sz="2400" b="0" dirty="0" err="1">
+                <a:solidFill>
+                  <a:srgbClr val="9ECE6A"/>
+                </a:solidFill>
+                <a:effectLst/>
+                <a:latin typeface="Consolas" panose="020B0609020204030204" pitchFamily="49" charset="0"/>
+                <a:ea typeface="Pretendard Variable Medium" panose="02000003000000020004" pitchFamily="2" charset="-127"/>
+              </a:rPr>
+              <a:t>z</a:t>
+            </a:r>
+            <a:r>
+              <a:rPr lang="en-US" altLang="ko-KR" sz="2400" b="0" dirty="0">
+                <a:solidFill>
+                  <a:srgbClr val="89DDFF"/>
+                </a:solidFill>
+                <a:effectLst/>
+                <a:latin typeface="Consolas" panose="020B0609020204030204" pitchFamily="49" charset="0"/>
+                <a:ea typeface="Pretendard Variable Medium" panose="02000003000000020004" pitchFamily="2" charset="-127"/>
+              </a:rPr>
+              <a:t>"</a:t>
+            </a:r>
+            <a:r>
+              <a:rPr lang="en-US" altLang="ko-KR" sz="2400" b="0" dirty="0">
+                <a:solidFill>
+                  <a:srgbClr val="9ABDF5"/>
+                </a:solidFill>
+                <a:effectLst/>
+                <a:latin typeface="Consolas" panose="020B0609020204030204" pitchFamily="49" charset="0"/>
+                <a:ea typeface="Pretendard Variable Medium" panose="02000003000000020004" pitchFamily="2" charset="-127"/>
+              </a:rPr>
+              <a:t>]</a:t>
+            </a:r>
+            <a:endParaRPr lang="en-US" altLang="ko-KR" sz="2400" b="0" dirty="0">
               <a:solidFill>
-                <a:srgbClr val="212529"/>
+                <a:srgbClr val="A9B1D6"/>
               </a:solidFill>
-              <a:latin typeface="+mn-ea"/>
+              <a:effectLst/>
+              <a:latin typeface="Consolas" panose="020B0609020204030204" pitchFamily="49" charset="0"/>
+              <a:ea typeface="Pretendard Variable Medium" panose="02000003000000020004" pitchFamily="2" charset="-127"/>
             </a:endParaRPr>
-          </a:p>
-          <a:p>
-            <a:pPr marL="457200" lvl="1" indent="0">
-              <a:buFont typeface="Arial" panose="020B0604020202020204" pitchFamily="34" charset="0"/>
-              <a:buNone/>
-            </a:pPr>
-            <a:endParaRPr lang="en-US" altLang="ko-KR" dirty="0">
-              <a:solidFill>
-                <a:srgbClr val="212529"/>
-              </a:solidFill>
-              <a:latin typeface="+mn-ea"/>
-            </a:endParaRPr>
-          </a:p>
-          <a:p>
-            <a:r>
-              <a:rPr lang="en-US" altLang="ko-KR" b="1" dirty="0">
-                <a:solidFill>
-                  <a:srgbClr val="212529"/>
-                </a:solidFill>
-                <a:latin typeface="+mn-ea"/>
-              </a:rPr>
-              <a:t>[</a:t>
-            </a:r>
-            <a:r>
-              <a:rPr lang="ko-KR" altLang="en-US" b="1" dirty="0" err="1">
-                <a:solidFill>
-                  <a:srgbClr val="212529"/>
-                </a:solidFill>
-                <a:latin typeface="+mn-ea"/>
-              </a:rPr>
-              <a:t>코딩온</a:t>
-            </a:r>
-            <a:r>
-              <a:rPr lang="en-US" altLang="ko-KR" b="1" dirty="0">
-                <a:solidFill>
-                  <a:srgbClr val="212529"/>
-                </a:solidFill>
-                <a:latin typeface="+mn-ea"/>
-              </a:rPr>
-              <a:t>] Node.js </a:t>
-            </a:r>
-            <a:r>
-              <a:rPr lang="ko-KR" altLang="en-US" b="1" dirty="0">
-                <a:solidFill>
-                  <a:srgbClr val="212529"/>
-                </a:solidFill>
-                <a:latin typeface="+mn-ea"/>
-              </a:rPr>
-              <a:t>실습</a:t>
-            </a:r>
-            <a:r>
-              <a:rPr lang="en-US" altLang="ko-KR" b="1" dirty="0">
-                <a:solidFill>
-                  <a:srgbClr val="212529"/>
-                </a:solidFill>
-                <a:latin typeface="+mn-ea"/>
-              </a:rPr>
-              <a:t> </a:t>
-            </a:r>
-            <a:r>
-              <a:rPr lang="ko-KR" altLang="en-US" dirty="0">
-                <a:solidFill>
-                  <a:srgbClr val="212529"/>
-                </a:solidFill>
-                <a:latin typeface="+mn-ea"/>
-              </a:rPr>
-              <a:t>강의 클릭</a:t>
-            </a:r>
-            <a:br>
-              <a:rPr lang="en-US" altLang="ko-KR" dirty="0">
-                <a:solidFill>
-                  <a:srgbClr val="212529"/>
-                </a:solidFill>
-                <a:latin typeface="+mn-ea"/>
-              </a:rPr>
-            </a:br>
-            <a:endParaRPr lang="en-US" altLang="ko-KR" dirty="0">
-              <a:solidFill>
-                <a:srgbClr val="212529"/>
-              </a:solidFill>
-              <a:latin typeface="+mn-ea"/>
-            </a:endParaRPr>
-          </a:p>
-          <a:p>
-            <a:pPr lvl="1"/>
-            <a:r>
-              <a:rPr lang="ko-KR" altLang="en-US" sz="2800" b="1" dirty="0">
-                <a:solidFill>
-                  <a:srgbClr val="212529"/>
-                </a:solidFill>
-                <a:latin typeface="+mn-ea"/>
-              </a:rPr>
-              <a:t>➡ </a:t>
-            </a:r>
-            <a:r>
-              <a:rPr lang="en-US" altLang="ko-KR" sz="2800" b="1" dirty="0">
-                <a:solidFill>
-                  <a:srgbClr val="212529"/>
-                </a:solidFill>
-                <a:latin typeface="+mn-ea"/>
-              </a:rPr>
-              <a:t>[…</a:t>
-            </a:r>
-            <a:r>
-              <a:rPr lang="ko-KR" altLang="en-US" sz="2800" b="1" dirty="0">
-                <a:solidFill>
-                  <a:srgbClr val="212529"/>
-                </a:solidFill>
-                <a:latin typeface="+mn-ea"/>
-              </a:rPr>
-              <a:t>연산자 실습</a:t>
-            </a:r>
-            <a:r>
-              <a:rPr lang="en-US" altLang="ko-KR" sz="2800" b="1" dirty="0">
-                <a:solidFill>
-                  <a:srgbClr val="212529"/>
-                </a:solidFill>
-                <a:latin typeface="+mn-ea"/>
-              </a:rPr>
-              <a:t>]</a:t>
-            </a:r>
-            <a:r>
-              <a:rPr lang="en-US" altLang="ko-KR" sz="2800" dirty="0">
-                <a:solidFill>
-                  <a:srgbClr val="212529"/>
-                </a:solidFill>
-                <a:latin typeface="+mn-ea"/>
-              </a:rPr>
-              <a:t> </a:t>
-            </a:r>
-            <a:r>
-              <a:rPr lang="ko-KR" altLang="en-US" sz="2800" dirty="0">
-                <a:solidFill>
-                  <a:srgbClr val="212529"/>
-                </a:solidFill>
-                <a:latin typeface="+mn-ea"/>
-              </a:rPr>
-              <a:t>커리큘럼 클릭</a:t>
-            </a:r>
-            <a:endParaRPr lang="en-US" altLang="ko-KR" sz="2800" dirty="0">
-              <a:solidFill>
-                <a:srgbClr val="212529"/>
-              </a:solidFill>
-              <a:latin typeface="+mn-ea"/>
-            </a:endParaRPr>
-          </a:p>
-          <a:p>
-            <a:pPr lvl="1"/>
-            <a:r>
-              <a:rPr lang="ko-KR" altLang="en-US" sz="2800" b="1" dirty="0">
-                <a:solidFill>
-                  <a:srgbClr val="212529"/>
-                </a:solidFill>
-                <a:latin typeface="+mn-ea"/>
-              </a:rPr>
-              <a:t>➡ </a:t>
-            </a:r>
-            <a:r>
-              <a:rPr lang="en-US" altLang="ko-KR" sz="2800" b="1" dirty="0">
-                <a:solidFill>
-                  <a:schemeClr val="accent1"/>
-                </a:solidFill>
-                <a:latin typeface="+mn-ea"/>
-              </a:rPr>
-              <a:t>[Spread </a:t>
-            </a:r>
-            <a:r>
-              <a:rPr lang="ko-KR" altLang="en-US" sz="2800" b="1" dirty="0">
-                <a:solidFill>
-                  <a:schemeClr val="accent1"/>
-                </a:solidFill>
-                <a:latin typeface="+mn-ea"/>
-              </a:rPr>
-              <a:t>연산자 사용하기</a:t>
-            </a:r>
-            <a:r>
-              <a:rPr lang="en-US" altLang="ko-KR" sz="2800" b="1" dirty="0">
-                <a:solidFill>
-                  <a:schemeClr val="accent1"/>
-                </a:solidFill>
-                <a:latin typeface="+mn-ea"/>
-              </a:rPr>
-              <a:t>]</a:t>
-            </a:r>
-            <a:r>
-              <a:rPr lang="en-US" altLang="ko-KR" sz="2800" dirty="0">
-                <a:solidFill>
-                  <a:schemeClr val="accent1"/>
-                </a:solidFill>
-                <a:latin typeface="+mn-ea"/>
-              </a:rPr>
-              <a:t> </a:t>
-            </a:r>
-            <a:r>
-              <a:rPr lang="ko-KR" altLang="en-US" sz="2800" dirty="0">
-                <a:solidFill>
-                  <a:srgbClr val="212529"/>
-                </a:solidFill>
-                <a:latin typeface="+mn-ea"/>
-              </a:rPr>
-              <a:t> 진행</a:t>
-            </a:r>
           </a:p>
         </p:txBody>
       </p:sp>
@@ -10332,7 +10380,7 @@
           <a:p>
             <a:fld id="{0E19CB95-6D28-40F1-9DA3-1BAC5D4B5B4F}" type="datetime6">
               <a:rPr lang="ko-KR" altLang="en-US" smtClean="0"/>
-              <a:t>2026년 1월</a:t>
+              <a:t>2026년 2월</a:t>
             </a:fld>
             <a:endParaRPr lang="ko-KR" altLang="en-US"/>
           </a:p>
@@ -10561,7 +10609,7 @@
           <a:p>
             <a:fld id="{9E387F8A-5546-492F-8DED-673FD4531098}" type="datetime6">
               <a:rPr lang="ko-KR" altLang="en-US" smtClean="0"/>
-              <a:t>2026년 1월</a:t>
+              <a:t>2026년 2월</a:t>
             </a:fld>
             <a:endParaRPr lang="ko-KR" altLang="en-US"/>
           </a:p>
@@ -11458,7 +11506,7 @@
           <a:p>
             <a:fld id="{0E19CB95-6D28-40F1-9DA3-1BAC5D4B5B4F}" type="datetime6">
               <a:rPr lang="ko-KR" altLang="en-US" smtClean="0"/>
-              <a:t>2026년 1월</a:t>
+              <a:t>2026년 2월</a:t>
             </a:fld>
             <a:endParaRPr lang="ko-KR" altLang="en-US"/>
           </a:p>
@@ -11695,7 +11743,7 @@
           <a:p>
             <a:fld id="{9E387F8A-5546-492F-8DED-673FD4531098}" type="datetime6">
               <a:rPr lang="ko-KR" altLang="en-US" smtClean="0"/>
-              <a:t>2026년 1월</a:t>
+              <a:t>2026년 2월</a:t>
             </a:fld>
             <a:endParaRPr lang="ko-KR" altLang="en-US"/>
           </a:p>
@@ -11873,7 +11921,7 @@
           <a:p>
             <a:fld id="{9E387F8A-5546-492F-8DED-673FD4531098}" type="datetime6">
               <a:rPr lang="ko-KR" altLang="en-US" smtClean="0"/>
-              <a:t>2026년 1월</a:t>
+              <a:t>2026년 2월</a:t>
             </a:fld>
             <a:endParaRPr lang="ko-KR" altLang="en-US"/>
           </a:p>
@@ -12876,7 +12924,7 @@
           <a:p>
             <a:fld id="{9E387F8A-5546-492F-8DED-673FD4531098}" type="datetime6">
               <a:rPr lang="ko-KR" altLang="en-US" smtClean="0"/>
-              <a:t>2026년 1월</a:t>
+              <a:t>2026년 2월</a:t>
             </a:fld>
             <a:endParaRPr lang="ko-KR" altLang="en-US"/>
           </a:p>
@@ -13280,7 +13328,7 @@
           <a:p>
             <a:fld id="{9E387F8A-5546-492F-8DED-673FD4531098}" type="datetime6">
               <a:rPr lang="ko-KR" altLang="en-US" smtClean="0"/>
-              <a:t>2026년 1월</a:t>
+              <a:t>2026년 2월</a:t>
             </a:fld>
             <a:endParaRPr lang="ko-KR" altLang="en-US"/>
           </a:p>
@@ -14088,7 +14136,7 @@
           <a:p>
             <a:fld id="{0E19CB95-6D28-40F1-9DA3-1BAC5D4B5B4F}" type="datetime6">
               <a:rPr lang="ko-KR" altLang="en-US" smtClean="0"/>
-              <a:t>2026년 1월</a:t>
+              <a:t>2026년 2월</a:t>
             </a:fld>
             <a:endParaRPr lang="ko-KR" altLang="en-US"/>
           </a:p>
@@ -14391,7 +14439,7 @@
           <a:p>
             <a:fld id="{9E387F8A-5546-492F-8DED-673FD4531098}" type="datetime6">
               <a:rPr lang="ko-KR" altLang="en-US" smtClean="0"/>
-              <a:t>2026년 1월</a:t>
+              <a:t>2026년 2월</a:t>
             </a:fld>
             <a:endParaRPr lang="ko-KR" altLang="en-US"/>
           </a:p>
@@ -14615,7 +14663,7 @@
           <a:p>
             <a:fld id="{9E387F8A-5546-492F-8DED-673FD4531098}" type="datetime6">
               <a:rPr lang="ko-KR" altLang="en-US" smtClean="0"/>
-              <a:t>2026년 1월</a:t>
+              <a:t>2026년 2월</a:t>
             </a:fld>
             <a:endParaRPr lang="ko-KR" altLang="en-US"/>
           </a:p>
@@ -15205,7 +15253,7 @@
           <a:p>
             <a:fld id="{9E387F8A-5546-492F-8DED-673FD4531098}" type="datetime6">
               <a:rPr lang="ko-KR" altLang="en-US" smtClean="0"/>
-              <a:t>2026년 1월</a:t>
+              <a:t>2026년 2월</a:t>
             </a:fld>
             <a:endParaRPr lang="ko-KR" altLang="en-US"/>
           </a:p>
@@ -16425,7 +16473,7 @@
           <a:p>
             <a:fld id="{9E387F8A-5546-492F-8DED-673FD4531098}" type="datetime6">
               <a:rPr lang="ko-KR" altLang="en-US" smtClean="0"/>
-              <a:t>2026년 1월</a:t>
+              <a:t>2026년 2월</a:t>
             </a:fld>
             <a:endParaRPr lang="ko-KR" altLang="en-US"/>
           </a:p>
@@ -17385,7 +17433,7 @@
           <a:p>
             <a:fld id="{0E19CB95-6D28-40F1-9DA3-1BAC5D4B5B4F}" type="datetime6">
               <a:rPr lang="ko-KR" altLang="en-US" smtClean="0"/>
-              <a:t>2026년 1월</a:t>
+              <a:t>2026년 2월</a:t>
             </a:fld>
             <a:endParaRPr lang="ko-KR" altLang="en-US"/>
           </a:p>
@@ -17567,7 +17615,7 @@
           <a:p>
             <a:fld id="{9E387F8A-5546-492F-8DED-673FD4531098}" type="datetime6">
               <a:rPr lang="ko-KR" altLang="en-US" smtClean="0"/>
-              <a:t>2026년 1월</a:t>
+              <a:t>2026년 2월</a:t>
             </a:fld>
             <a:endParaRPr lang="ko-KR" altLang="en-US"/>
           </a:p>
@@ -18766,7 +18814,7 @@
           <a:p>
             <a:fld id="{9E387F8A-5546-492F-8DED-673FD4531098}" type="datetime6">
               <a:rPr lang="ko-KR" altLang="en-US" smtClean="0"/>
-              <a:t>2026년 1월</a:t>
+              <a:t>2026년 2월</a:t>
             </a:fld>
             <a:endParaRPr lang="ko-KR" altLang="en-US"/>
           </a:p>
@@ -18891,7 +18939,7 @@
           <a:p>
             <a:fld id="{9E387F8A-5546-492F-8DED-673FD4531098}" type="datetime6">
               <a:rPr lang="ko-KR" altLang="en-US" smtClean="0"/>
-              <a:t>2026년 1월</a:t>
+              <a:t>2026년 2월</a:t>
             </a:fld>
             <a:endParaRPr lang="ko-KR" altLang="en-US"/>
           </a:p>
@@ -19295,7 +19343,7 @@
           <a:p>
             <a:fld id="{0E19CB95-6D28-40F1-9DA3-1BAC5D4B5B4F}" type="datetime6">
               <a:rPr lang="ko-KR" altLang="en-US" smtClean="0"/>
-              <a:t>2026년 1월</a:t>
+              <a:t>2026년 2월</a:t>
             </a:fld>
             <a:endParaRPr lang="ko-KR" altLang="en-US"/>
           </a:p>
@@ -19596,7 +19644,7 @@
           <a:p>
             <a:fld id="{9E387F8A-5546-492F-8DED-673FD4531098}" type="datetime6">
               <a:rPr lang="ko-KR" altLang="en-US" smtClean="0"/>
-              <a:t>2026년 1월</a:t>
+              <a:t>2026년 2월</a:t>
             </a:fld>
             <a:endParaRPr lang="ko-KR" altLang="en-US"/>
           </a:p>
@@ -19955,7 +20003,7 @@
           <a:p>
             <a:fld id="{9E387F8A-5546-492F-8DED-673FD4531098}" type="datetime6">
               <a:rPr lang="ko-KR" altLang="en-US" smtClean="0"/>
-              <a:t>2026년 1월</a:t>
+              <a:t>2026년 2월</a:t>
             </a:fld>
             <a:endParaRPr lang="ko-KR" altLang="en-US"/>
           </a:p>
@@ -20271,7 +20319,7 @@
           <a:p>
             <a:fld id="{3C9CE3CE-253F-4F9D-BA15-C226C8D8501E}" type="datetime6">
               <a:rPr lang="ko-KR" altLang="en-US" smtClean="0"/>
-              <a:t>2026년 1월</a:t>
+              <a:t>2026년 2월</a:t>
             </a:fld>
             <a:endParaRPr lang="ko-KR" altLang="en-US"/>
           </a:p>
@@ -20695,7 +20743,7 @@
           <a:p>
             <a:fld id="{9E387F8A-5546-492F-8DED-673FD4531098}" type="datetime6">
               <a:rPr lang="ko-KR" altLang="en-US" smtClean="0"/>
-              <a:t>2026년 1월</a:t>
+              <a:t>2026년 2월</a:t>
             </a:fld>
             <a:endParaRPr lang="ko-KR" altLang="en-US"/>
           </a:p>
@@ -21601,7 +21649,7 @@
           <a:p>
             <a:fld id="{9E387F8A-5546-492F-8DED-673FD4531098}" type="datetime6">
               <a:rPr lang="ko-KR" altLang="en-US" smtClean="0"/>
-              <a:t>2026년 1월</a:t>
+              <a:t>2026년 2월</a:t>
             </a:fld>
             <a:endParaRPr lang="ko-KR" altLang="en-US"/>
           </a:p>
@@ -22671,7 +22719,7 @@
           <a:p>
             <a:fld id="{9E387F8A-5546-492F-8DED-673FD4531098}" type="datetime6">
               <a:rPr lang="ko-KR" altLang="en-US" smtClean="0"/>
-              <a:t>2026년 1월</a:t>
+              <a:t>2026년 2월</a:t>
             </a:fld>
             <a:endParaRPr lang="ko-KR" altLang="en-US"/>
           </a:p>
@@ -23283,7 +23331,7 @@
           <a:p>
             <a:fld id="{0F78D9C4-20C1-4B15-A116-16DC77AD9A1E}" type="datetime1">
               <a:rPr lang="ko-KR" altLang="en-US" smtClean="0"/>
-              <a:t>2026-01-06</a:t>
+              <a:t>2026-02-02</a:t>
             </a:fld>
             <a:endParaRPr lang="ko-KR" altLang="en-US"/>
           </a:p>
@@ -23401,7 +23449,7 @@
           <a:p>
             <a:fld id="{9E387F8A-5546-492F-8DED-673FD4531098}" type="datetime6">
               <a:rPr lang="ko-KR" altLang="en-US" smtClean="0"/>
-              <a:t>2026년 1월</a:t>
+              <a:t>2026년 2월</a:t>
             </a:fld>
             <a:endParaRPr lang="ko-KR" altLang="en-US"/>
           </a:p>
@@ -24018,7 +24066,7 @@
           <a:p>
             <a:fld id="{9E387F8A-5546-492F-8DED-673FD4531098}" type="datetime6">
               <a:rPr lang="ko-KR" altLang="en-US" smtClean="0"/>
-              <a:t>2026년 1월</a:t>
+              <a:t>2026년 2월</a:t>
             </a:fld>
             <a:endParaRPr lang="ko-KR" altLang="en-US"/>
           </a:p>
@@ -25024,7 +25072,7 @@
           <a:p>
             <a:fld id="{9E387F8A-5546-492F-8DED-673FD4531098}" type="datetime6">
               <a:rPr lang="ko-KR" altLang="en-US" smtClean="0"/>
-              <a:t>2026년 1월</a:t>
+              <a:t>2026년 2월</a:t>
             </a:fld>
             <a:endParaRPr lang="ko-KR" altLang="en-US"/>
           </a:p>
@@ -25646,7 +25694,7 @@
           <a:p>
             <a:fld id="{9E387F8A-5546-492F-8DED-673FD4531098}" type="datetime6">
               <a:rPr lang="ko-KR" altLang="en-US" smtClean="0"/>
-              <a:t>2026년 1월</a:t>
+              <a:t>2026년 2월</a:t>
             </a:fld>
             <a:endParaRPr lang="ko-KR" altLang="en-US"/>
           </a:p>
@@ -26868,7 +26916,7 @@
           <a:p>
             <a:fld id="{9E387F8A-5546-492F-8DED-673FD4531098}" type="datetime6">
               <a:rPr lang="ko-KR" altLang="en-US" smtClean="0"/>
-              <a:t>2026년 1월</a:t>
+              <a:t>2026년 2월</a:t>
             </a:fld>
             <a:endParaRPr lang="ko-KR" altLang="en-US"/>
           </a:p>
@@ -27820,7 +27868,7 @@
           <a:p>
             <a:fld id="{0E19CB95-6D28-40F1-9DA3-1BAC5D4B5B4F}" type="datetime6">
               <a:rPr lang="ko-KR" altLang="en-US" smtClean="0"/>
-              <a:t>2026년 1월</a:t>
+              <a:t>2026년 2월</a:t>
             </a:fld>
             <a:endParaRPr lang="ko-KR" altLang="en-US"/>
           </a:p>
@@ -28368,7 +28416,7 @@
           <a:p>
             <a:fld id="{0F78D9C4-20C1-4B15-A116-16DC77AD9A1E}" type="datetime1">
               <a:rPr lang="ko-KR" altLang="en-US" smtClean="0"/>
-              <a:t>2026-01-06</a:t>
+              <a:t>2026-02-02</a:t>
             </a:fld>
             <a:endParaRPr lang="ko-KR" altLang="en-US"/>
           </a:p>
@@ -29038,7 +29086,7 @@
           <a:p>
             <a:fld id="{9E387F8A-5546-492F-8DED-673FD4531098}" type="datetime6">
               <a:rPr lang="ko-KR" altLang="en-US" smtClean="0"/>
-              <a:t>2026년 1월</a:t>
+              <a:t>2026년 2월</a:t>
             </a:fld>
             <a:endParaRPr lang="ko-KR" altLang="en-US"/>
           </a:p>
@@ -29794,7 +29842,7 @@
           <a:p>
             <a:fld id="{0F78D9C4-20C1-4B15-A116-16DC77AD9A1E}" type="datetime1">
               <a:rPr lang="ko-KR" altLang="en-US" smtClean="0"/>
-              <a:t>2026-01-06</a:t>
+              <a:t>2026-02-02</a:t>
             </a:fld>
             <a:endParaRPr lang="ko-KR" altLang="en-US"/>
           </a:p>
@@ -29889,10 +29937,10 @@
       </p:grpSpPr>
       <p:sp>
         <p:nvSpPr>
-          <p:cNvPr id="13" name="내용 개체 틀 2">
+          <p:cNvPr id="2" name="제목 1">
             <a:extLst>
               <a:ext uri="{FF2B5EF4-FFF2-40B4-BE49-F238E27FC236}">
-                <a16:creationId xmlns:a16="http://schemas.microsoft.com/office/drawing/2014/main" id="{847FD532-7F61-A001-537F-B970BD821AF3}"/>
+                <a16:creationId xmlns:a16="http://schemas.microsoft.com/office/drawing/2014/main" id="{D1B8A310-1A1F-09FC-4A9E-98188CCD3C40}"/>
               </a:ext>
             </a:extLst>
           </p:cNvPr>
@@ -29900,40 +29948,52 @@
             <a:spLocks noGrp="1"/>
           </p:cNvSpPr>
           <p:nvPr>
-            <p:ph idx="1"/>
+            <p:ph type="title"/>
           </p:nvPr>
         </p:nvSpPr>
-        <p:spPr>
-          <a:xfrm>
-            <a:off x="510988" y="1328391"/>
-            <a:ext cx="11260802" cy="5328442"/>
-          </a:xfrm>
-        </p:spPr>
-        <p:txBody>
-          <a:bodyPr>
-            <a:normAutofit/>
-          </a:bodyPr>
+        <p:spPr/>
+        <p:txBody>
+          <a:bodyPr/>
           <a:lstStyle/>
           <a:p>
-            <a:endParaRPr lang="en-US" altLang="ko-KR" dirty="0"/>
-          </a:p>
-          <a:p>
-            <a:pPr marL="0" indent="0">
-              <a:buNone/>
-            </a:pPr>
-            <a:endParaRPr lang="en-US" altLang="ko-KR" dirty="0"/>
-          </a:p>
-          <a:p>
-            <a:endParaRPr lang="en-US" altLang="ko-KR" dirty="0"/>
-          </a:p>
-        </p:txBody>
-      </p:sp>
-      <p:sp>
-        <p:nvSpPr>
-          <p:cNvPr id="4" name="날짜 개체 틀 3">
+            <a:r>
+              <a:rPr lang="ko-KR" altLang="en-US" dirty="0">
+                <a:solidFill>
+                  <a:srgbClr val="ED7D31"/>
+                </a:solidFill>
+              </a:rPr>
+              <a:t>실습</a:t>
+            </a:r>
+            <a:r>
+              <a:rPr lang="en-US" altLang="ko-KR" dirty="0">
+                <a:solidFill>
+                  <a:srgbClr val="ED7D31"/>
+                </a:solidFill>
+              </a:rPr>
+              <a:t>1. </a:t>
+            </a:r>
+            <a:r>
+              <a:rPr lang="en-US" altLang="ko-KR" dirty="0">
+                <a:solidFill>
+                  <a:schemeClr val="accent2"/>
+                </a:solidFill>
+              </a:rPr>
+              <a:t>Callback -&gt; Promise</a:t>
+            </a:r>
+            <a:endParaRPr lang="ko-KR" altLang="en-US" dirty="0">
+              <a:solidFill>
+                <a:schemeClr val="accent2"/>
+              </a:solidFill>
+            </a:endParaRPr>
+          </a:p>
+        </p:txBody>
+      </p:sp>
+      <p:sp>
+        <p:nvSpPr>
+          <p:cNvPr id="3" name="날짜 개체 틀 2">
             <a:extLst>
               <a:ext uri="{FF2B5EF4-FFF2-40B4-BE49-F238E27FC236}">
-                <a16:creationId xmlns:a16="http://schemas.microsoft.com/office/drawing/2014/main" id="{A695DDE5-0A39-A366-4CFE-A283911999CD}"/>
+                <a16:creationId xmlns:a16="http://schemas.microsoft.com/office/drawing/2014/main" id="{6C33EE99-62C7-4220-ABBA-B056CAC671FC}"/>
               </a:ext>
             </a:extLst>
           </p:cNvPr>
@@ -29949,9 +30009,9 @@
           <a:bodyPr/>
           <a:lstStyle/>
           <a:p>
-            <a:fld id="{0F78D9C4-20C1-4B15-A116-16DC77AD9A1E}" type="datetime1">
+            <a:fld id="{9E387F8A-5546-492F-8DED-673FD4531098}" type="datetime6">
               <a:rPr lang="ko-KR" altLang="en-US" smtClean="0"/>
-              <a:t>2026-01-06</a:t>
+              <a:t>2026년 2월</a:t>
             </a:fld>
             <a:endParaRPr lang="ko-KR" altLang="en-US"/>
           </a:p>
@@ -29959,10 +30019,10 @@
       </p:sp>
       <p:sp>
         <p:nvSpPr>
-          <p:cNvPr id="5" name="슬라이드 번호 개체 틀 4">
+          <p:cNvPr id="4" name="슬라이드 번호 개체 틀 3">
             <a:extLst>
               <a:ext uri="{FF2B5EF4-FFF2-40B4-BE49-F238E27FC236}">
-                <a16:creationId xmlns:a16="http://schemas.microsoft.com/office/drawing/2014/main" id="{5E040F43-60A7-C50D-1F5B-F984054F2D7C}"/>
+                <a16:creationId xmlns:a16="http://schemas.microsoft.com/office/drawing/2014/main" id="{F3EFD188-FCCD-74C3-81B0-73381D2D4ADB}"/>
               </a:ext>
             </a:extLst>
           </p:cNvPr>
@@ -29986,63 +30046,42 @@
           </a:p>
         </p:txBody>
       </p:sp>
-      <p:sp>
-        <p:nvSpPr>
-          <p:cNvPr id="2" name="제목 1">
+      <p:pic>
+        <p:nvPicPr>
+          <p:cNvPr id="6" name="그림 5">
             <a:extLst>
               <a:ext uri="{FF2B5EF4-FFF2-40B4-BE49-F238E27FC236}">
-                <a16:creationId xmlns:a16="http://schemas.microsoft.com/office/drawing/2014/main" id="{5FAC57F5-99D7-9C46-B6C1-D16224151FE9}"/>
+                <a16:creationId xmlns:a16="http://schemas.microsoft.com/office/drawing/2014/main" id="{DCEE5727-8986-8102-F687-8730B3F3B6BB}"/>
               </a:ext>
             </a:extLst>
           </p:cNvPr>
-          <p:cNvSpPr>
-            <a:spLocks noGrp="1"/>
-          </p:cNvSpPr>
-          <p:nvPr>
-            <p:ph type="title"/>
-          </p:nvPr>
-        </p:nvSpPr>
-        <p:spPr/>
-        <p:txBody>
-          <a:bodyPr/>
-          <a:lstStyle/>
-          <a:p>
-            <a:r>
-              <a:rPr lang="ko-KR" altLang="en-US" dirty="0">
-                <a:solidFill>
-                  <a:srgbClr val="ED7D31"/>
-                </a:solidFill>
-                <a:latin typeface="+mj-ea"/>
-              </a:rPr>
-              <a:t>실습</a:t>
-            </a:r>
-            <a:r>
-              <a:rPr lang="en-US" altLang="ko-KR" dirty="0">
-                <a:solidFill>
-                  <a:srgbClr val="ED7D31"/>
-                </a:solidFill>
-                <a:latin typeface="+mj-ea"/>
-              </a:rPr>
-              <a:t>. Promise </a:t>
-            </a:r>
-            <a:r>
-              <a:rPr lang="ko-KR" altLang="en-US" dirty="0">
-                <a:solidFill>
-                  <a:srgbClr val="ED7D31"/>
-                </a:solidFill>
-                <a:latin typeface="+mj-ea"/>
-              </a:rPr>
-              <a:t>사용하기</a:t>
-            </a:r>
-          </a:p>
-        </p:txBody>
-      </p:sp>
-      <p:sp>
-        <p:nvSpPr>
-          <p:cNvPr id="6" name="내용 개체 틀 1">
+          <p:cNvPicPr>
+            <a:picLocks noChangeAspect="1"/>
+          </p:cNvPicPr>
+          <p:nvPr/>
+        </p:nvPicPr>
+        <p:blipFill>
+          <a:blip r:embed="rId3"/>
+          <a:stretch>
+            <a:fillRect/>
+          </a:stretch>
+        </p:blipFill>
+        <p:spPr>
+          <a:xfrm>
+            <a:off x="8407093" y="4119162"/>
+            <a:ext cx="3080713" cy="1981648"/>
+          </a:xfrm>
+          <a:prstGeom prst="rect">
+            <a:avLst/>
+          </a:prstGeom>
+        </p:spPr>
+      </p:pic>
+      <p:sp>
+        <p:nvSpPr>
+          <p:cNvPr id="8" name="내용 개체 틀 7">
             <a:extLst>
               <a:ext uri="{FF2B5EF4-FFF2-40B4-BE49-F238E27FC236}">
-                <a16:creationId xmlns:a16="http://schemas.microsoft.com/office/drawing/2014/main" id="{70C2BA37-BE91-39C4-AC08-0E8A1052E2F7}"/>
+                <a16:creationId xmlns:a16="http://schemas.microsoft.com/office/drawing/2014/main" id="{208F257A-9753-45A8-56FA-C9F2943D7E86}"/>
               </a:ext>
             </a:extLst>
           </p:cNvPr>
@@ -30053,8 +30092,8 @@
         </p:nvSpPr>
         <p:spPr>
           <a:xfrm>
-            <a:off x="838200" y="1825625"/>
-            <a:ext cx="10515600" cy="4351338"/>
+            <a:off x="8407093" y="3716568"/>
+            <a:ext cx="2499441" cy="386006"/>
           </a:xfrm>
           <a:prstGeom prst="rect">
             <a:avLst/>
@@ -30062,12 +30101,12 @@
         </p:spPr>
         <p:txBody>
           <a:bodyPr vert="horz" lIns="91440" tIns="45720" rIns="91440" bIns="45720" rtlCol="0">
-            <a:normAutofit/>
+            <a:noAutofit/>
           </a:bodyPr>
           <a:lstStyle>
             <a:lvl1pPr marL="228600" indent="-228600" algn="l" defTabSz="914400" rtl="0" eaLnBrk="1" latinLnBrk="1" hangingPunct="1">
               <a:lnSpc>
-                <a:spcPct val="90000"/>
+                <a:spcPct val="120000"/>
               </a:lnSpc>
               <a:spcBef>
                 <a:spcPts val="1000"/>
@@ -30085,7 +30124,7 @@
             </a:lvl1pPr>
             <a:lvl2pPr marL="685800" indent="-228600" algn="l" defTabSz="914400" rtl="0" eaLnBrk="1" latinLnBrk="1" hangingPunct="1">
               <a:lnSpc>
-                <a:spcPct val="90000"/>
+                <a:spcPct val="120000"/>
               </a:lnSpc>
               <a:spcBef>
                 <a:spcPts val="500"/>
@@ -30103,7 +30142,7 @@
             </a:lvl2pPr>
             <a:lvl3pPr marL="1143000" indent="-228600" algn="l" defTabSz="914400" rtl="0" eaLnBrk="1" latinLnBrk="1" hangingPunct="1">
               <a:lnSpc>
-                <a:spcPct val="90000"/>
+                <a:spcPct val="120000"/>
               </a:lnSpc>
               <a:spcBef>
                 <a:spcPts val="500"/>
@@ -30121,7 +30160,7 @@
             </a:lvl3pPr>
             <a:lvl4pPr marL="1600200" indent="-228600" algn="l" defTabSz="914400" rtl="0" eaLnBrk="1" latinLnBrk="1" hangingPunct="1">
               <a:lnSpc>
-                <a:spcPct val="90000"/>
+                <a:spcPct val="120000"/>
               </a:lnSpc>
               <a:spcBef>
                 <a:spcPts val="500"/>
@@ -30139,7 +30178,7 @@
             </a:lvl4pPr>
             <a:lvl5pPr marL="2057400" indent="-228600" algn="l" defTabSz="914400" rtl="0" eaLnBrk="1" latinLnBrk="1" hangingPunct="1">
               <a:lnSpc>
-                <a:spcPct val="90000"/>
+                <a:spcPct val="120000"/>
               </a:lnSpc>
               <a:spcBef>
                 <a:spcPts val="500"/>
@@ -30229,226 +30268,314 @@
             </a:lvl9pPr>
           </a:lstStyle>
           <a:p>
-            <a:pPr marL="457200" lvl="1" indent="0">
-              <a:buFont typeface="Arial" panose="020B0604020202020204" pitchFamily="34" charset="0"/>
+            <a:pPr marL="0" indent="0">
               <a:buNone/>
             </a:pPr>
-            <a:endParaRPr lang="en-US" altLang="ko-KR" dirty="0">
-              <a:solidFill>
-                <a:srgbClr val="212529"/>
-              </a:solidFill>
-            </a:endParaRPr>
-          </a:p>
-          <a:p>
-            <a:pPr marL="457200" lvl="1" indent="0">
+            <a:r>
+              <a:rPr lang="ko-KR" altLang="en-US" sz="2000" b="1" dirty="0"/>
+              <a:t>🚀 실행 결과</a:t>
+            </a:r>
+          </a:p>
+        </p:txBody>
+      </p:sp>
+      <p:pic>
+        <p:nvPicPr>
+          <p:cNvPr id="11" name="그림 10">
+            <a:extLst>
+              <a:ext uri="{FF2B5EF4-FFF2-40B4-BE49-F238E27FC236}">
+                <a16:creationId xmlns:a16="http://schemas.microsoft.com/office/drawing/2014/main" id="{D7E78DFF-615F-676F-5AAF-11B8261A56AC}"/>
+              </a:ext>
+            </a:extLst>
+          </p:cNvPr>
+          <p:cNvPicPr>
+            <a:picLocks noChangeAspect="1"/>
+          </p:cNvPicPr>
+          <p:nvPr/>
+        </p:nvPicPr>
+        <p:blipFill>
+          <a:blip r:embed="rId4"/>
+          <a:stretch>
+            <a:fillRect/>
+          </a:stretch>
+        </p:blipFill>
+        <p:spPr>
+          <a:xfrm>
+            <a:off x="704194" y="1329936"/>
+            <a:ext cx="3456502" cy="4773265"/>
+          </a:xfrm>
+          <a:prstGeom prst="rect">
+            <a:avLst/>
+          </a:prstGeom>
+        </p:spPr>
+      </p:pic>
+      <p:pic>
+        <p:nvPicPr>
+          <p:cNvPr id="13" name="그림 12">
+            <a:extLst>
+              <a:ext uri="{FF2B5EF4-FFF2-40B4-BE49-F238E27FC236}">
+                <a16:creationId xmlns:a16="http://schemas.microsoft.com/office/drawing/2014/main" id="{E704B37A-E9B9-8DF5-ED7D-C45570D2DF0B}"/>
+              </a:ext>
+            </a:extLst>
+          </p:cNvPr>
+          <p:cNvPicPr>
+            <a:picLocks noChangeAspect="1"/>
+          </p:cNvPicPr>
+          <p:nvPr/>
+        </p:nvPicPr>
+        <p:blipFill>
+          <a:blip r:embed="rId5"/>
+          <a:stretch>
+            <a:fillRect/>
+          </a:stretch>
+        </p:blipFill>
+        <p:spPr>
+          <a:xfrm>
+            <a:off x="4280079" y="3799251"/>
+            <a:ext cx="3631842" cy="2303950"/>
+          </a:xfrm>
+          <a:prstGeom prst="rect">
+            <a:avLst/>
+          </a:prstGeom>
+        </p:spPr>
+      </p:pic>
+      <p:sp>
+        <p:nvSpPr>
+          <p:cNvPr id="14" name="내용 개체 틀 7">
+            <a:extLst>
+              <a:ext uri="{FF2B5EF4-FFF2-40B4-BE49-F238E27FC236}">
+                <a16:creationId xmlns:a16="http://schemas.microsoft.com/office/drawing/2014/main" id="{0602D83E-556D-A659-E4C3-692DA793AE98}"/>
+              </a:ext>
+            </a:extLst>
+          </p:cNvPr>
+          <p:cNvSpPr txBox="1">
+            <a:spLocks/>
+          </p:cNvSpPr>
+          <p:nvPr/>
+        </p:nvSpPr>
+        <p:spPr>
+          <a:xfrm>
+            <a:off x="4385814" y="1325563"/>
+            <a:ext cx="7290983" cy="1368922"/>
+          </a:xfrm>
+          <a:prstGeom prst="rect">
+            <a:avLst/>
+          </a:prstGeom>
+        </p:spPr>
+        <p:txBody>
+          <a:bodyPr vert="horz" lIns="91440" tIns="45720" rIns="91440" bIns="45720" rtlCol="0">
+            <a:normAutofit/>
+          </a:bodyPr>
+          <a:lstStyle>
+            <a:lvl1pPr marL="228600" indent="-228600" algn="l" defTabSz="914400" rtl="0" eaLnBrk="1" latinLnBrk="1" hangingPunct="1">
+              <a:lnSpc>
+                <a:spcPct val="120000"/>
+              </a:lnSpc>
+              <a:spcBef>
+                <a:spcPts val="1000"/>
+              </a:spcBef>
               <a:buFont typeface="Arial" panose="020B0604020202020204" pitchFamily="34" charset="0"/>
+              <a:buChar char="•"/>
+              <a:defRPr sz="2800" kern="1200">
+                <a:solidFill>
+                  <a:schemeClr val="tx1"/>
+                </a:solidFill>
+                <a:latin typeface="+mn-lt"/>
+                <a:ea typeface="+mn-ea"/>
+                <a:cs typeface="+mn-cs"/>
+              </a:defRPr>
+            </a:lvl1pPr>
+            <a:lvl2pPr marL="685800" indent="-228600" algn="l" defTabSz="914400" rtl="0" eaLnBrk="1" latinLnBrk="1" hangingPunct="1">
+              <a:lnSpc>
+                <a:spcPct val="120000"/>
+              </a:lnSpc>
+              <a:spcBef>
+                <a:spcPts val="500"/>
+              </a:spcBef>
+              <a:buFont typeface="Arial" panose="020B0604020202020204" pitchFamily="34" charset="0"/>
+              <a:buChar char="•"/>
+              <a:defRPr sz="2400" kern="1200">
+                <a:solidFill>
+                  <a:schemeClr val="tx1"/>
+                </a:solidFill>
+                <a:latin typeface="+mn-lt"/>
+                <a:ea typeface="+mn-ea"/>
+                <a:cs typeface="+mn-cs"/>
+              </a:defRPr>
+            </a:lvl2pPr>
+            <a:lvl3pPr marL="1143000" indent="-228600" algn="l" defTabSz="914400" rtl="0" eaLnBrk="1" latinLnBrk="1" hangingPunct="1">
+              <a:lnSpc>
+                <a:spcPct val="120000"/>
+              </a:lnSpc>
+              <a:spcBef>
+                <a:spcPts val="500"/>
+              </a:spcBef>
+              <a:buFont typeface="Arial" panose="020B0604020202020204" pitchFamily="34" charset="0"/>
+              <a:buChar char="•"/>
+              <a:defRPr sz="2000" kern="1200">
+                <a:solidFill>
+                  <a:schemeClr val="tx1"/>
+                </a:solidFill>
+                <a:latin typeface="+mn-lt"/>
+                <a:ea typeface="+mn-ea"/>
+                <a:cs typeface="+mn-cs"/>
+              </a:defRPr>
+            </a:lvl3pPr>
+            <a:lvl4pPr marL="1600200" indent="-228600" algn="l" defTabSz="914400" rtl="0" eaLnBrk="1" latinLnBrk="1" hangingPunct="1">
+              <a:lnSpc>
+                <a:spcPct val="120000"/>
+              </a:lnSpc>
+              <a:spcBef>
+                <a:spcPts val="500"/>
+              </a:spcBef>
+              <a:buFont typeface="Arial" panose="020B0604020202020204" pitchFamily="34" charset="0"/>
+              <a:buChar char="•"/>
+              <a:defRPr sz="1800" kern="1200">
+                <a:solidFill>
+                  <a:schemeClr val="tx1"/>
+                </a:solidFill>
+                <a:latin typeface="+mn-lt"/>
+                <a:ea typeface="+mn-ea"/>
+                <a:cs typeface="+mn-cs"/>
+              </a:defRPr>
+            </a:lvl4pPr>
+            <a:lvl5pPr marL="2057400" indent="-228600" algn="l" defTabSz="914400" rtl="0" eaLnBrk="1" latinLnBrk="1" hangingPunct="1">
+              <a:lnSpc>
+                <a:spcPct val="120000"/>
+              </a:lnSpc>
+              <a:spcBef>
+                <a:spcPts val="500"/>
+              </a:spcBef>
+              <a:buFont typeface="Arial" panose="020B0604020202020204" pitchFamily="34" charset="0"/>
+              <a:buChar char="•"/>
+              <a:defRPr sz="1800" kern="1200">
+                <a:solidFill>
+                  <a:schemeClr val="tx1"/>
+                </a:solidFill>
+                <a:latin typeface="+mn-lt"/>
+                <a:ea typeface="+mn-ea"/>
+                <a:cs typeface="+mn-cs"/>
+              </a:defRPr>
+            </a:lvl5pPr>
+            <a:lvl6pPr marL="2514600" indent="-228600" algn="l" defTabSz="914400" rtl="0" eaLnBrk="1" latinLnBrk="1" hangingPunct="1">
+              <a:lnSpc>
+                <a:spcPct val="90000"/>
+              </a:lnSpc>
+              <a:spcBef>
+                <a:spcPts val="500"/>
+              </a:spcBef>
+              <a:buFont typeface="Arial" panose="020B0604020202020204" pitchFamily="34" charset="0"/>
+              <a:buChar char="•"/>
+              <a:defRPr sz="1800" kern="1200">
+                <a:solidFill>
+                  <a:schemeClr val="tx1"/>
+                </a:solidFill>
+                <a:latin typeface="+mn-lt"/>
+                <a:ea typeface="+mn-ea"/>
+                <a:cs typeface="+mn-cs"/>
+              </a:defRPr>
+            </a:lvl6pPr>
+            <a:lvl7pPr marL="2971800" indent="-228600" algn="l" defTabSz="914400" rtl="0" eaLnBrk="1" latinLnBrk="1" hangingPunct="1">
+              <a:lnSpc>
+                <a:spcPct val="90000"/>
+              </a:lnSpc>
+              <a:spcBef>
+                <a:spcPts val="500"/>
+              </a:spcBef>
+              <a:buFont typeface="Arial" panose="020B0604020202020204" pitchFamily="34" charset="0"/>
+              <a:buChar char="•"/>
+              <a:defRPr sz="1800" kern="1200">
+                <a:solidFill>
+                  <a:schemeClr val="tx1"/>
+                </a:solidFill>
+                <a:latin typeface="+mn-lt"/>
+                <a:ea typeface="+mn-ea"/>
+                <a:cs typeface="+mn-cs"/>
+              </a:defRPr>
+            </a:lvl7pPr>
+            <a:lvl8pPr marL="3429000" indent="-228600" algn="l" defTabSz="914400" rtl="0" eaLnBrk="1" latinLnBrk="1" hangingPunct="1">
+              <a:lnSpc>
+                <a:spcPct val="90000"/>
+              </a:lnSpc>
+              <a:spcBef>
+                <a:spcPts val="500"/>
+              </a:spcBef>
+              <a:buFont typeface="Arial" panose="020B0604020202020204" pitchFamily="34" charset="0"/>
+              <a:buChar char="•"/>
+              <a:defRPr sz="1800" kern="1200">
+                <a:solidFill>
+                  <a:schemeClr val="tx1"/>
+                </a:solidFill>
+                <a:latin typeface="+mn-lt"/>
+                <a:ea typeface="+mn-ea"/>
+                <a:cs typeface="+mn-cs"/>
+              </a:defRPr>
+            </a:lvl8pPr>
+            <a:lvl9pPr marL="3886200" indent="-228600" algn="l" defTabSz="914400" rtl="0" eaLnBrk="1" latinLnBrk="1" hangingPunct="1">
+              <a:lnSpc>
+                <a:spcPct val="90000"/>
+              </a:lnSpc>
+              <a:spcBef>
+                <a:spcPts val="500"/>
+              </a:spcBef>
+              <a:buFont typeface="Arial" panose="020B0604020202020204" pitchFamily="34" charset="0"/>
+              <a:buChar char="•"/>
+              <a:defRPr sz="1800" kern="1200">
+                <a:solidFill>
+                  <a:schemeClr val="tx1"/>
+                </a:solidFill>
+                <a:latin typeface="+mn-lt"/>
+                <a:ea typeface="+mn-ea"/>
+                <a:cs typeface="+mn-cs"/>
+              </a:defRPr>
+            </a:lvl9pPr>
+          </a:lstStyle>
+          <a:p>
+            <a:pPr marL="0" indent="0">
               <a:buNone/>
             </a:pPr>
-            <a:endParaRPr lang="en-US" altLang="ko-KR" dirty="0">
-              <a:solidFill>
-                <a:srgbClr val="212529"/>
-              </a:solidFill>
-            </a:endParaRPr>
-          </a:p>
-          <a:p>
-            <a:r>
-              <a:rPr lang="en-US" altLang="ko-KR" b="1" dirty="0">
-                <a:solidFill>
-                  <a:srgbClr val="212529"/>
-                </a:solidFill>
-              </a:rPr>
-              <a:t>[</a:t>
-            </a:r>
-            <a:r>
-              <a:rPr lang="ko-KR" altLang="en-US" b="1" dirty="0" err="1">
-                <a:solidFill>
-                  <a:srgbClr val="212529"/>
-                </a:solidFill>
-              </a:rPr>
-              <a:t>코딩온</a:t>
-            </a:r>
-            <a:r>
-              <a:rPr lang="en-US" altLang="ko-KR" b="1" dirty="0">
-                <a:solidFill>
-                  <a:srgbClr val="212529"/>
-                </a:solidFill>
-              </a:rPr>
-              <a:t>] Node.js </a:t>
-            </a:r>
-            <a:r>
-              <a:rPr lang="ko-KR" altLang="en-US" b="1" dirty="0">
-                <a:solidFill>
-                  <a:srgbClr val="212529"/>
-                </a:solidFill>
-              </a:rPr>
-              <a:t>실습</a:t>
-            </a:r>
-            <a:r>
-              <a:rPr lang="en-US" altLang="ko-KR" b="1" dirty="0">
-                <a:solidFill>
-                  <a:srgbClr val="212529"/>
-                </a:solidFill>
-              </a:rPr>
-              <a:t> </a:t>
+            <a:r>
+              <a:rPr lang="ko-KR" altLang="en-US" dirty="0" err="1">
+                <a:solidFill>
+                  <a:schemeClr val="tx1">
+                    <a:lumMod val="95000"/>
+                    <a:lumOff val="5000"/>
+                  </a:schemeClr>
+                </a:solidFill>
+              </a:rPr>
+              <a:t>콜백</a:t>
             </a:r>
             <a:r>
               <a:rPr lang="ko-KR" altLang="en-US" dirty="0">
                 <a:solidFill>
-                  <a:srgbClr val="212529"/>
-                </a:solidFill>
-              </a:rPr>
-              <a:t>강의 클릭</a:t>
-            </a:r>
-            <a:br>
+                  <a:schemeClr val="tx1">
+                    <a:lumMod val="95000"/>
+                    <a:lumOff val="5000"/>
+                  </a:schemeClr>
+                </a:solidFill>
+              </a:rPr>
+              <a:t> 함수로 이루어진 코드를 </a:t>
+            </a:r>
+            <a:r>
               <a:rPr lang="en-US" altLang="ko-KR" dirty="0">
                 <a:solidFill>
-                  <a:srgbClr val="212529"/>
-                </a:solidFill>
-              </a:rPr>
-            </a:br>
-            <a:endParaRPr lang="en-US" altLang="ko-KR" dirty="0">
-              <a:solidFill>
-                <a:srgbClr val="212529"/>
-              </a:solidFill>
-            </a:endParaRPr>
-          </a:p>
-          <a:p>
-            <a:pPr lvl="1"/>
-            <a:r>
-              <a:rPr lang="ko-KR" altLang="en-US" sz="2800" b="1" dirty="0">
-                <a:solidFill>
-                  <a:srgbClr val="212529"/>
-                </a:solidFill>
-              </a:rPr>
-              <a:t>➡ </a:t>
-            </a:r>
-            <a:r>
-              <a:rPr lang="en-US" altLang="ko-KR" sz="2800" b="1" dirty="0">
-                <a:solidFill>
-                  <a:srgbClr val="212529"/>
-                </a:solidFill>
-              </a:rPr>
-              <a:t>[Async</a:t>
-            </a:r>
-            <a:r>
-              <a:rPr lang="ko-KR" altLang="en-US" sz="2800" b="1" dirty="0">
-                <a:solidFill>
-                  <a:srgbClr val="212529"/>
-                </a:solidFill>
-              </a:rPr>
-              <a:t> </a:t>
-            </a:r>
-            <a:r>
-              <a:rPr lang="en-US" altLang="ko-KR" sz="2800" b="1" dirty="0">
-                <a:solidFill>
-                  <a:srgbClr val="212529"/>
-                </a:solidFill>
-              </a:rPr>
-              <a:t>/</a:t>
-            </a:r>
-            <a:r>
-              <a:rPr lang="ko-KR" altLang="en-US" sz="2800" b="1" dirty="0">
-                <a:solidFill>
-                  <a:srgbClr val="212529"/>
-                </a:solidFill>
-              </a:rPr>
-              <a:t> </a:t>
-            </a:r>
-            <a:r>
-              <a:rPr lang="en-US" altLang="ko-KR" sz="2800" b="1" dirty="0">
-                <a:solidFill>
-                  <a:srgbClr val="212529"/>
-                </a:solidFill>
-              </a:rPr>
-              <a:t>Await</a:t>
-            </a:r>
-            <a:r>
-              <a:rPr lang="ko-KR" altLang="en-US" sz="2800" b="1" dirty="0">
-                <a:solidFill>
-                  <a:srgbClr val="212529"/>
-                </a:solidFill>
-              </a:rPr>
-              <a:t> 실습</a:t>
-            </a:r>
-            <a:r>
-              <a:rPr lang="en-US" altLang="ko-KR" sz="2800" b="1" dirty="0">
-                <a:solidFill>
-                  <a:srgbClr val="212529"/>
-                </a:solidFill>
-              </a:rPr>
-              <a:t>]</a:t>
-            </a:r>
-            <a:r>
-              <a:rPr lang="en-US" altLang="ko-KR" sz="2800" dirty="0">
-                <a:solidFill>
-                  <a:srgbClr val="212529"/>
-                </a:solidFill>
-              </a:rPr>
-              <a:t> </a:t>
-            </a:r>
-            <a:r>
-              <a:rPr lang="ko-KR" altLang="en-US" sz="2800" dirty="0">
-                <a:solidFill>
-                  <a:srgbClr val="212529"/>
-                </a:solidFill>
-              </a:rPr>
-              <a:t>커리큘럼 클릭</a:t>
-            </a:r>
-            <a:endParaRPr lang="en-US" altLang="ko-KR" sz="2800" dirty="0">
-              <a:solidFill>
-                <a:srgbClr val="212529"/>
-              </a:solidFill>
-            </a:endParaRPr>
-          </a:p>
-          <a:p>
-            <a:pPr lvl="1"/>
-            <a:r>
-              <a:rPr lang="ko-KR" altLang="en-US" sz="2800" b="1" dirty="0">
-                <a:solidFill>
-                  <a:srgbClr val="212529"/>
-                </a:solidFill>
-              </a:rPr>
-              <a:t>➡ </a:t>
-            </a:r>
-            <a:r>
-              <a:rPr lang="en-US" altLang="ko-KR" sz="2800" b="1" dirty="0">
-                <a:solidFill>
-                  <a:schemeClr val="accent1"/>
-                </a:solidFill>
-              </a:rPr>
-              <a:t>[Promise </a:t>
-            </a:r>
-            <a:r>
-              <a:rPr lang="ko-KR" altLang="en-US" sz="2800" b="1" dirty="0">
-                <a:solidFill>
-                  <a:schemeClr val="accent1"/>
-                </a:solidFill>
-              </a:rPr>
-              <a:t>사용하기</a:t>
-            </a:r>
-            <a:r>
-              <a:rPr lang="en-US" altLang="ko-KR" sz="2800" b="1" dirty="0">
-                <a:solidFill>
-                  <a:schemeClr val="accent1"/>
-                </a:solidFill>
-              </a:rPr>
-              <a:t>]</a:t>
-            </a:r>
-            <a:r>
-              <a:rPr lang="en-US" altLang="ko-KR" sz="2800" dirty="0">
-                <a:solidFill>
-                  <a:schemeClr val="accent1"/>
-                </a:solidFill>
-              </a:rPr>
-              <a:t> </a:t>
-            </a:r>
-            <a:r>
-              <a:rPr lang="ko-KR" altLang="en-US" sz="2800" dirty="0">
-                <a:solidFill>
-                  <a:srgbClr val="212529"/>
-                </a:solidFill>
-              </a:rPr>
-              <a:t> 진행</a:t>
+                  <a:schemeClr val="tx1">
+                    <a:lumMod val="95000"/>
+                    <a:lumOff val="5000"/>
+                  </a:schemeClr>
+                </a:solidFill>
+              </a:rPr>
+              <a:t>Promise</a:t>
+            </a:r>
+            <a:r>
+              <a:rPr lang="ko-KR" altLang="en-US" dirty="0">
+                <a:solidFill>
+                  <a:schemeClr val="tx1">
+                    <a:lumMod val="95000"/>
+                    <a:lumOff val="5000"/>
+                  </a:schemeClr>
+                </a:solidFill>
+              </a:rPr>
+              <a:t>로 변경하기</a:t>
             </a:r>
           </a:p>
         </p:txBody>
@@ -30456,7 +30583,7 @@
     </p:spTree>
     <p:extLst>
       <p:ext uri="{BB962C8B-B14F-4D97-AF65-F5344CB8AC3E}">
-        <p14:creationId xmlns:p14="http://schemas.microsoft.com/office/powerpoint/2010/main" val="259966667"/>
+        <p14:creationId xmlns:p14="http://schemas.microsoft.com/office/powerpoint/2010/main" val="2567990880"/>
       </p:ext>
     </p:extLst>
   </p:cSld>
@@ -30485,10 +30612,133 @@
       </p:grpSpPr>
       <p:sp>
         <p:nvSpPr>
-          <p:cNvPr id="13" name="내용 개체 틀 2">
+          <p:cNvPr id="2" name="제목 1">
             <a:extLst>
               <a:ext uri="{FF2B5EF4-FFF2-40B4-BE49-F238E27FC236}">
-                <a16:creationId xmlns:a16="http://schemas.microsoft.com/office/drawing/2014/main" id="{847FD532-7F61-A001-537F-B970BD821AF3}"/>
+                <a16:creationId xmlns:a16="http://schemas.microsoft.com/office/drawing/2014/main" id="{D1B8A310-1A1F-09FC-4A9E-98188CCD3C40}"/>
+              </a:ext>
+            </a:extLst>
+          </p:cNvPr>
+          <p:cNvSpPr>
+            <a:spLocks noGrp="1"/>
+          </p:cNvSpPr>
+          <p:nvPr>
+            <p:ph type="title"/>
+          </p:nvPr>
+        </p:nvSpPr>
+        <p:spPr/>
+        <p:txBody>
+          <a:bodyPr/>
+          <a:lstStyle/>
+          <a:p>
+            <a:r>
+              <a:rPr lang="ko-KR" altLang="en-US" dirty="0">
+                <a:solidFill>
+                  <a:srgbClr val="ED7D31"/>
+                </a:solidFill>
+              </a:rPr>
+              <a:t>실습</a:t>
+            </a:r>
+            <a:r>
+              <a:rPr lang="en-US" altLang="ko-KR" dirty="0">
+                <a:solidFill>
+                  <a:srgbClr val="ED7D31"/>
+                </a:solidFill>
+              </a:rPr>
+              <a:t>2</a:t>
+            </a:r>
+            <a:r>
+              <a:rPr lang="en-US" altLang="ko-KR" dirty="0">
+                <a:solidFill>
+                  <a:schemeClr val="accent2"/>
+                </a:solidFill>
+              </a:rPr>
+              <a:t>.</a:t>
+            </a:r>
+            <a:r>
+              <a:rPr lang="en-US" altLang="ko-KR" dirty="0"/>
+              <a:t> </a:t>
+            </a:r>
+            <a:r>
+              <a:rPr lang="en-US" altLang="ko-KR" dirty="0">
+                <a:solidFill>
+                  <a:schemeClr val="accent2"/>
+                </a:solidFill>
+              </a:rPr>
+              <a:t>Promise - async/await</a:t>
+            </a:r>
+            <a:endParaRPr lang="ko-KR" altLang="en-US" dirty="0">
+              <a:solidFill>
+                <a:schemeClr val="accent2"/>
+              </a:solidFill>
+            </a:endParaRPr>
+          </a:p>
+        </p:txBody>
+      </p:sp>
+      <p:sp>
+        <p:nvSpPr>
+          <p:cNvPr id="3" name="날짜 개체 틀 2">
+            <a:extLst>
+              <a:ext uri="{FF2B5EF4-FFF2-40B4-BE49-F238E27FC236}">
+                <a16:creationId xmlns:a16="http://schemas.microsoft.com/office/drawing/2014/main" id="{6C33EE99-62C7-4220-ABBA-B056CAC671FC}"/>
+              </a:ext>
+            </a:extLst>
+          </p:cNvPr>
+          <p:cNvSpPr>
+            <a:spLocks noGrp="1"/>
+          </p:cNvSpPr>
+          <p:nvPr>
+            <p:ph type="dt" sz="half" idx="10"/>
+          </p:nvPr>
+        </p:nvSpPr>
+        <p:spPr/>
+        <p:txBody>
+          <a:bodyPr/>
+          <a:lstStyle/>
+          <a:p>
+            <a:fld id="{9E387F8A-5546-492F-8DED-673FD4531098}" type="datetime6">
+              <a:rPr lang="ko-KR" altLang="en-US" smtClean="0"/>
+              <a:t>2026년 2월</a:t>
+            </a:fld>
+            <a:endParaRPr lang="ko-KR" altLang="en-US"/>
+          </a:p>
+        </p:txBody>
+      </p:sp>
+      <p:sp>
+        <p:nvSpPr>
+          <p:cNvPr id="4" name="슬라이드 번호 개체 틀 3">
+            <a:extLst>
+              <a:ext uri="{FF2B5EF4-FFF2-40B4-BE49-F238E27FC236}">
+                <a16:creationId xmlns:a16="http://schemas.microsoft.com/office/drawing/2014/main" id="{F3EFD188-FCCD-74C3-81B0-73381D2D4ADB}"/>
+              </a:ext>
+            </a:extLst>
+          </p:cNvPr>
+          <p:cNvSpPr>
+            <a:spLocks noGrp="1"/>
+          </p:cNvSpPr>
+          <p:nvPr>
+            <p:ph type="sldNum" sz="quarter" idx="12"/>
+          </p:nvPr>
+        </p:nvSpPr>
+        <p:spPr/>
+        <p:txBody>
+          <a:bodyPr/>
+          <a:lstStyle/>
+          <a:p>
+            <a:fld id="{083A2CE0-18CD-4102-B738-4ACFF9E68BA4}" type="slidenum">
+              <a:rPr lang="ko-KR" altLang="en-US" smtClean="0"/>
+              <a:t>51</a:t>
+            </a:fld>
+            <a:endParaRPr lang="ko-KR" altLang="en-US"/>
+          </a:p>
+        </p:txBody>
+      </p:sp>
+      <p:sp>
+        <p:nvSpPr>
+          <p:cNvPr id="5" name="내용 개체 틀 7">
+            <a:extLst>
+              <a:ext uri="{FF2B5EF4-FFF2-40B4-BE49-F238E27FC236}">
+                <a16:creationId xmlns:a16="http://schemas.microsoft.com/office/drawing/2014/main" id="{11487B41-A202-BE61-B09C-97ECDFE989C5}"/>
               </a:ext>
             </a:extLst>
           </p:cNvPr>
@@ -30501,8 +30751,8 @@
         </p:nvSpPr>
         <p:spPr>
           <a:xfrm>
-            <a:off x="510988" y="1328391"/>
-            <a:ext cx="11260802" cy="5328442"/>
+            <a:off x="827313" y="1325563"/>
+            <a:ext cx="10299865" cy="4558228"/>
           </a:xfrm>
         </p:spPr>
         <p:txBody>
@@ -30511,144 +30761,188 @@
           </a:bodyPr>
           <a:lstStyle/>
           <a:p>
-            <a:endParaRPr lang="en-US" altLang="ko-KR" dirty="0"/>
-          </a:p>
-          <a:p>
             <a:pPr marL="0" indent="0">
               <a:buNone/>
             </a:pPr>
+            <a:r>
+              <a:rPr lang="ko-KR" altLang="en-US" b="1" dirty="0"/>
+              <a:t>실습</a:t>
+            </a:r>
+            <a:r>
+              <a:rPr lang="en-US" altLang="ko-KR" b="1" dirty="0"/>
+              <a:t>1</a:t>
+            </a:r>
+            <a:r>
+              <a:rPr lang="en-US" altLang="ko-KR" dirty="0"/>
+              <a:t> </a:t>
+            </a:r>
+            <a:r>
+              <a:rPr lang="ko-KR" altLang="en-US" dirty="0"/>
+              <a:t>에서 </a:t>
+            </a:r>
+            <a:r>
+              <a:rPr lang="en-US" altLang="ko-KR" dirty="0"/>
+              <a:t>promise</a:t>
+            </a:r>
+            <a:r>
+              <a:rPr lang="ko-KR" altLang="en-US" dirty="0"/>
+              <a:t>로 바꾼 코드를 </a:t>
+            </a:r>
+            <a:r>
+              <a:rPr lang="en-US" altLang="ko-KR" dirty="0"/>
+              <a:t>exec </a:t>
+            </a:r>
+            <a:r>
+              <a:rPr lang="ko-KR" altLang="en-US" dirty="0"/>
+              <a:t>함수를 만들어 실행하게 하기</a:t>
+            </a:r>
             <a:endParaRPr lang="en-US" altLang="ko-KR" dirty="0"/>
           </a:p>
           <a:p>
-            <a:endParaRPr lang="en-US" altLang="ko-KR" dirty="0"/>
-          </a:p>
-        </p:txBody>
-      </p:sp>
-      <p:sp>
-        <p:nvSpPr>
-          <p:cNvPr id="4" name="날짜 개체 틀 3">
+            <a:pPr marL="0" indent="0">
+              <a:buNone/>
+            </a:pPr>
+            <a:r>
+              <a:rPr lang="en-US" altLang="ko-KR" dirty="0"/>
+              <a:t>(</a:t>
+            </a:r>
+            <a:r>
+              <a:rPr lang="ko-KR" altLang="en-US" dirty="0"/>
+              <a:t>이때</a:t>
+            </a:r>
+            <a:r>
+              <a:rPr lang="en-US" altLang="ko-KR" dirty="0"/>
+              <a:t>, exec</a:t>
+            </a:r>
+            <a:r>
+              <a:rPr lang="ko-KR" altLang="en-US" dirty="0"/>
+              <a:t>는 </a:t>
+            </a:r>
+            <a:r>
+              <a:rPr lang="en-US" altLang="ko-KR" dirty="0"/>
+              <a:t>async </a:t>
+            </a:r>
+            <a:r>
+              <a:rPr lang="ko-KR" altLang="en-US" dirty="0"/>
+              <a:t>함수이다</a:t>
+            </a:r>
+            <a:r>
+              <a:rPr lang="en-US" altLang="ko-KR" dirty="0"/>
+              <a:t>.)</a:t>
+            </a:r>
+          </a:p>
+        </p:txBody>
+      </p:sp>
+      <p:pic>
+        <p:nvPicPr>
+          <p:cNvPr id="7" name="그림 6">
             <a:extLst>
               <a:ext uri="{FF2B5EF4-FFF2-40B4-BE49-F238E27FC236}">
-                <a16:creationId xmlns:a16="http://schemas.microsoft.com/office/drawing/2014/main" id="{A695DDE5-0A39-A366-4CFE-A283911999CD}"/>
+                <a16:creationId xmlns:a16="http://schemas.microsoft.com/office/drawing/2014/main" id="{DB19BD58-0014-DC5B-0C8F-68277244E818}"/>
               </a:ext>
             </a:extLst>
           </p:cNvPr>
-          <p:cNvSpPr>
-            <a:spLocks noGrp="1"/>
-          </p:cNvSpPr>
-          <p:nvPr>
-            <p:ph type="dt" sz="half" idx="10"/>
-          </p:nvPr>
-        </p:nvSpPr>
-        <p:spPr/>
-        <p:txBody>
-          <a:bodyPr/>
-          <a:lstStyle/>
-          <a:p>
-            <a:fld id="{0F78D9C4-20C1-4B15-A116-16DC77AD9A1E}" type="datetime1">
-              <a:rPr lang="ko-KR" altLang="en-US" smtClean="0"/>
-              <a:t>2026-01-06</a:t>
-            </a:fld>
-            <a:endParaRPr lang="ko-KR" altLang="en-US"/>
-          </a:p>
-        </p:txBody>
-      </p:sp>
-      <p:sp>
-        <p:nvSpPr>
-          <p:cNvPr id="5" name="슬라이드 번호 개체 틀 4">
+          <p:cNvPicPr>
+            <a:picLocks noChangeAspect="1"/>
+          </p:cNvPicPr>
+          <p:nvPr/>
+        </p:nvPicPr>
+        <p:blipFill>
+          <a:blip r:embed="rId3"/>
+          <a:stretch>
+            <a:fillRect/>
+          </a:stretch>
+        </p:blipFill>
+        <p:spPr>
+          <a:xfrm>
+            <a:off x="6199838" y="3219073"/>
+            <a:ext cx="5320028" cy="2889106"/>
+          </a:xfrm>
+          <a:prstGeom prst="rect">
+            <a:avLst/>
+          </a:prstGeom>
+        </p:spPr>
+      </p:pic>
+      <p:sp>
+        <p:nvSpPr>
+          <p:cNvPr id="9" name="TextBox 8">
             <a:extLst>
               <a:ext uri="{FF2B5EF4-FFF2-40B4-BE49-F238E27FC236}">
-                <a16:creationId xmlns:a16="http://schemas.microsoft.com/office/drawing/2014/main" id="{5E040F43-60A7-C50D-1F5B-F984054F2D7C}"/>
+                <a16:creationId xmlns:a16="http://schemas.microsoft.com/office/drawing/2014/main" id="{647DAAD4-1E7E-48FE-233E-0E7C8D8A579F}"/>
               </a:ext>
             </a:extLst>
           </p:cNvPr>
-          <p:cNvSpPr>
-            <a:spLocks noGrp="1"/>
-          </p:cNvSpPr>
-          <p:nvPr>
-            <p:ph type="sldNum" sz="quarter" idx="12"/>
-          </p:nvPr>
-        </p:nvSpPr>
-        <p:spPr/>
-        <p:txBody>
-          <a:bodyPr/>
+          <p:cNvSpPr txBox="1"/>
+          <p:nvPr/>
+        </p:nvSpPr>
+        <p:spPr>
+          <a:xfrm>
+            <a:off x="8440506" y="2563516"/>
+            <a:ext cx="1109599" cy="523220"/>
+          </a:xfrm>
+          <a:prstGeom prst="rect">
+            <a:avLst/>
+          </a:prstGeom>
+          <a:noFill/>
+        </p:spPr>
+        <p:txBody>
+          <a:bodyPr wrap="none" rtlCol="0">
+            <a:spAutoFit/>
+          </a:bodyPr>
           <a:lstStyle/>
           <a:p>
-            <a:fld id="{083A2CE0-18CD-4102-B738-4ACFF9E68BA4}" type="slidenum">
-              <a:rPr lang="ko-KR" altLang="en-US" smtClean="0"/>
-              <a:t>51</a:t>
-            </a:fld>
-            <a:endParaRPr lang="ko-KR" altLang="en-US"/>
-          </a:p>
-        </p:txBody>
-      </p:sp>
-      <p:sp>
-        <p:nvSpPr>
-          <p:cNvPr id="2" name="제목 1">
+            <a:r>
+              <a:rPr lang="en-US" altLang="ko-KR" sz="2800" dirty="0">
+                <a:highlight>
+                  <a:srgbClr val="FFFF00"/>
+                </a:highlight>
+              </a:rPr>
+              <a:t>Hint!!</a:t>
+            </a:r>
+            <a:endParaRPr lang="ko-KR" altLang="en-US" sz="2800" dirty="0">
+              <a:highlight>
+                <a:srgbClr val="FFFF00"/>
+              </a:highlight>
+            </a:endParaRPr>
+          </a:p>
+        </p:txBody>
+      </p:sp>
+      <p:pic>
+        <p:nvPicPr>
+          <p:cNvPr id="6" name="그림 5">
             <a:extLst>
               <a:ext uri="{FF2B5EF4-FFF2-40B4-BE49-F238E27FC236}">
-                <a16:creationId xmlns:a16="http://schemas.microsoft.com/office/drawing/2014/main" id="{5FAC57F5-99D7-9C46-B6C1-D16224151FE9}"/>
+                <a16:creationId xmlns:a16="http://schemas.microsoft.com/office/drawing/2014/main" id="{E513ED75-6EED-DD2F-F68F-ECF4FEEBF7FF}"/>
               </a:ext>
             </a:extLst>
           </p:cNvPr>
-          <p:cNvSpPr>
-            <a:spLocks noGrp="1"/>
-          </p:cNvSpPr>
-          <p:nvPr>
-            <p:ph type="title"/>
-          </p:nvPr>
-        </p:nvSpPr>
-        <p:spPr/>
-        <p:txBody>
-          <a:bodyPr/>
-          <a:lstStyle/>
-          <a:p>
-            <a:r>
-              <a:rPr lang="ko-KR" altLang="en-US" dirty="0">
-                <a:solidFill>
-                  <a:srgbClr val="ED7D31"/>
-                </a:solidFill>
-              </a:rPr>
-              <a:t>실습</a:t>
-            </a:r>
-            <a:r>
-              <a:rPr lang="en-US" altLang="ko-KR" dirty="0">
-                <a:solidFill>
-                  <a:srgbClr val="ED7D31"/>
-                </a:solidFill>
-              </a:rPr>
-              <a:t>. Promise </a:t>
-            </a:r>
-            <a:r>
-              <a:rPr lang="ko-KR" altLang="en-US" dirty="0">
-                <a:solidFill>
-                  <a:srgbClr val="ED7D31"/>
-                </a:solidFill>
-              </a:rPr>
-              <a:t>사용하기 </a:t>
-            </a:r>
-            <a:r>
-              <a:rPr lang="en-US" altLang="ko-KR" dirty="0">
-                <a:solidFill>
-                  <a:srgbClr val="ED7D31"/>
-                </a:solidFill>
-              </a:rPr>
-              <a:t>(2)</a:t>
-            </a:r>
-            <a:endParaRPr lang="ko-KR" altLang="en-US" dirty="0">
-              <a:solidFill>
-                <a:srgbClr val="ED7D31"/>
-              </a:solidFill>
-            </a:endParaRPr>
-          </a:p>
-        </p:txBody>
-      </p:sp>
-      <p:sp>
-        <p:nvSpPr>
-          <p:cNvPr id="6" name="내용 개체 틀 1">
+          <p:cNvPicPr>
+            <a:picLocks noChangeAspect="1"/>
+          </p:cNvPicPr>
+          <p:nvPr/>
+        </p:nvPicPr>
+        <p:blipFill>
+          <a:blip r:embed="rId4"/>
+          <a:stretch>
+            <a:fillRect/>
+          </a:stretch>
+        </p:blipFill>
+        <p:spPr>
+          <a:xfrm>
+            <a:off x="827313" y="4126531"/>
+            <a:ext cx="3080713" cy="1981648"/>
+          </a:xfrm>
+          <a:prstGeom prst="rect">
+            <a:avLst/>
+          </a:prstGeom>
+        </p:spPr>
+      </p:pic>
+      <p:sp>
+        <p:nvSpPr>
+          <p:cNvPr id="8" name="내용 개체 틀 7">
             <a:extLst>
               <a:ext uri="{FF2B5EF4-FFF2-40B4-BE49-F238E27FC236}">
-                <a16:creationId xmlns:a16="http://schemas.microsoft.com/office/drawing/2014/main" id="{70C2BA37-BE91-39C4-AC08-0E8A1052E2F7}"/>
+                <a16:creationId xmlns:a16="http://schemas.microsoft.com/office/drawing/2014/main" id="{81CEFBD6-BFDA-04DB-F203-1FA75231D9BA}"/>
               </a:ext>
             </a:extLst>
           </p:cNvPr>
@@ -30659,8 +30953,8 @@
         </p:nvSpPr>
         <p:spPr>
           <a:xfrm>
-            <a:off x="838200" y="1825625"/>
-            <a:ext cx="10515600" cy="4351338"/>
+            <a:off x="827313" y="3723937"/>
+            <a:ext cx="2499441" cy="386006"/>
           </a:xfrm>
           <a:prstGeom prst="rect">
             <a:avLst/>
@@ -30668,12 +30962,12 @@
         </p:spPr>
         <p:txBody>
           <a:bodyPr vert="horz" lIns="91440" tIns="45720" rIns="91440" bIns="45720" rtlCol="0">
-            <a:normAutofit/>
+            <a:noAutofit/>
           </a:bodyPr>
           <a:lstStyle>
             <a:lvl1pPr marL="228600" indent="-228600" algn="l" defTabSz="914400" rtl="0" eaLnBrk="1" latinLnBrk="1" hangingPunct="1">
               <a:lnSpc>
-                <a:spcPct val="90000"/>
+                <a:spcPct val="120000"/>
               </a:lnSpc>
               <a:spcBef>
                 <a:spcPts val="1000"/>
@@ -30691,7 +30985,7 @@
             </a:lvl1pPr>
             <a:lvl2pPr marL="685800" indent="-228600" algn="l" defTabSz="914400" rtl="0" eaLnBrk="1" latinLnBrk="1" hangingPunct="1">
               <a:lnSpc>
-                <a:spcPct val="90000"/>
+                <a:spcPct val="120000"/>
               </a:lnSpc>
               <a:spcBef>
                 <a:spcPts val="500"/>
@@ -30709,7 +31003,7 @@
             </a:lvl2pPr>
             <a:lvl3pPr marL="1143000" indent="-228600" algn="l" defTabSz="914400" rtl="0" eaLnBrk="1" latinLnBrk="1" hangingPunct="1">
               <a:lnSpc>
-                <a:spcPct val="90000"/>
+                <a:spcPct val="120000"/>
               </a:lnSpc>
               <a:spcBef>
                 <a:spcPts val="500"/>
@@ -30727,7 +31021,7 @@
             </a:lvl3pPr>
             <a:lvl4pPr marL="1600200" indent="-228600" algn="l" defTabSz="914400" rtl="0" eaLnBrk="1" latinLnBrk="1" hangingPunct="1">
               <a:lnSpc>
-                <a:spcPct val="90000"/>
+                <a:spcPct val="120000"/>
               </a:lnSpc>
               <a:spcBef>
                 <a:spcPts val="500"/>
@@ -30745,7 +31039,7 @@
             </a:lvl4pPr>
             <a:lvl5pPr marL="2057400" indent="-228600" algn="l" defTabSz="914400" rtl="0" eaLnBrk="1" latinLnBrk="1" hangingPunct="1">
               <a:lnSpc>
-                <a:spcPct val="90000"/>
+                <a:spcPct val="120000"/>
               </a:lnSpc>
               <a:spcBef>
                 <a:spcPts val="500"/>
@@ -30835,253 +31129,12 @@
             </a:lvl9pPr>
           </a:lstStyle>
           <a:p>
-            <a:pPr marL="457200" lvl="1" indent="0">
-              <a:buFont typeface="Arial" panose="020B0604020202020204" pitchFamily="34" charset="0"/>
+            <a:pPr marL="0" indent="0">
               <a:buNone/>
             </a:pPr>
-            <a:endParaRPr lang="en-US" altLang="ko-KR" dirty="0">
-              <a:solidFill>
-                <a:srgbClr val="212529"/>
-              </a:solidFill>
-              <a:latin typeface="+mn-ea"/>
-            </a:endParaRPr>
-          </a:p>
-          <a:p>
-            <a:pPr marL="457200" lvl="1" indent="0">
-              <a:buFont typeface="Arial" panose="020B0604020202020204" pitchFamily="34" charset="0"/>
-              <a:buNone/>
-            </a:pPr>
-            <a:endParaRPr lang="en-US" altLang="ko-KR" dirty="0">
-              <a:solidFill>
-                <a:srgbClr val="212529"/>
-              </a:solidFill>
-              <a:latin typeface="+mn-ea"/>
-            </a:endParaRPr>
-          </a:p>
-          <a:p>
-            <a:r>
-              <a:rPr lang="en-US" altLang="ko-KR" b="1" dirty="0">
-                <a:solidFill>
-                  <a:srgbClr val="212529"/>
-                </a:solidFill>
-                <a:latin typeface="+mn-ea"/>
-              </a:rPr>
-              <a:t>[</a:t>
-            </a:r>
-            <a:r>
-              <a:rPr lang="ko-KR" altLang="en-US" b="1" dirty="0" err="1">
-                <a:solidFill>
-                  <a:srgbClr val="212529"/>
-                </a:solidFill>
-                <a:latin typeface="+mn-ea"/>
-              </a:rPr>
-              <a:t>코딩온</a:t>
-            </a:r>
-            <a:r>
-              <a:rPr lang="en-US" altLang="ko-KR" b="1" dirty="0">
-                <a:solidFill>
-                  <a:srgbClr val="212529"/>
-                </a:solidFill>
-                <a:latin typeface="+mn-ea"/>
-              </a:rPr>
-              <a:t>] Node.js </a:t>
-            </a:r>
-            <a:r>
-              <a:rPr lang="ko-KR" altLang="en-US" b="1" dirty="0">
-                <a:solidFill>
-                  <a:srgbClr val="212529"/>
-                </a:solidFill>
-                <a:latin typeface="+mn-ea"/>
-              </a:rPr>
-              <a:t>실습</a:t>
-            </a:r>
-            <a:r>
-              <a:rPr lang="en-US" altLang="ko-KR" b="1" dirty="0">
-                <a:solidFill>
-                  <a:srgbClr val="212529"/>
-                </a:solidFill>
-                <a:latin typeface="+mn-ea"/>
-              </a:rPr>
-              <a:t> </a:t>
-            </a:r>
-            <a:r>
-              <a:rPr lang="ko-KR" altLang="en-US" dirty="0">
-                <a:solidFill>
-                  <a:srgbClr val="212529"/>
-                </a:solidFill>
-                <a:latin typeface="+mn-ea"/>
-              </a:rPr>
-              <a:t>강의 클릭</a:t>
-            </a:r>
-            <a:br>
-              <a:rPr lang="en-US" altLang="ko-KR" dirty="0">
-                <a:solidFill>
-                  <a:srgbClr val="212529"/>
-                </a:solidFill>
-                <a:latin typeface="+mn-ea"/>
-              </a:rPr>
-            </a:br>
-            <a:endParaRPr lang="en-US" altLang="ko-KR" dirty="0">
-              <a:solidFill>
-                <a:srgbClr val="212529"/>
-              </a:solidFill>
-              <a:latin typeface="+mn-ea"/>
-            </a:endParaRPr>
-          </a:p>
-          <a:p>
-            <a:pPr lvl="1"/>
-            <a:r>
-              <a:rPr lang="ko-KR" altLang="en-US" sz="2800" b="1" dirty="0">
-                <a:solidFill>
-                  <a:srgbClr val="212529"/>
-                </a:solidFill>
-                <a:latin typeface="+mn-ea"/>
-              </a:rPr>
-              <a:t>➡ </a:t>
-            </a:r>
-            <a:r>
-              <a:rPr lang="en-US" altLang="ko-KR" sz="2800" b="1" dirty="0">
-                <a:solidFill>
-                  <a:srgbClr val="212529"/>
-                </a:solidFill>
-                <a:latin typeface="+mn-ea"/>
-              </a:rPr>
-              <a:t>[Async</a:t>
-            </a:r>
-            <a:r>
-              <a:rPr lang="ko-KR" altLang="en-US" sz="2800" b="1" dirty="0">
-                <a:solidFill>
-                  <a:srgbClr val="212529"/>
-                </a:solidFill>
-                <a:latin typeface="+mn-ea"/>
-              </a:rPr>
-              <a:t> </a:t>
-            </a:r>
-            <a:r>
-              <a:rPr lang="en-US" altLang="ko-KR" sz="2800" b="1" dirty="0">
-                <a:solidFill>
-                  <a:srgbClr val="212529"/>
-                </a:solidFill>
-                <a:latin typeface="+mn-ea"/>
-              </a:rPr>
-              <a:t>/</a:t>
-            </a:r>
-            <a:r>
-              <a:rPr lang="ko-KR" altLang="en-US" sz="2800" b="1" dirty="0">
-                <a:solidFill>
-                  <a:srgbClr val="212529"/>
-                </a:solidFill>
-                <a:latin typeface="+mn-ea"/>
-              </a:rPr>
-              <a:t> </a:t>
-            </a:r>
-            <a:r>
-              <a:rPr lang="en-US" altLang="ko-KR" sz="2800" b="1" dirty="0">
-                <a:solidFill>
-                  <a:srgbClr val="212529"/>
-                </a:solidFill>
-                <a:latin typeface="+mn-ea"/>
-              </a:rPr>
-              <a:t>Await</a:t>
-            </a:r>
-            <a:r>
-              <a:rPr lang="ko-KR" altLang="en-US" sz="2800" b="1" dirty="0">
-                <a:solidFill>
-                  <a:srgbClr val="212529"/>
-                </a:solidFill>
-                <a:latin typeface="+mn-ea"/>
-              </a:rPr>
-              <a:t> 실습</a:t>
-            </a:r>
-            <a:r>
-              <a:rPr lang="en-US" altLang="ko-KR" sz="2800" b="1" dirty="0">
-                <a:solidFill>
-                  <a:srgbClr val="212529"/>
-                </a:solidFill>
-                <a:latin typeface="+mn-ea"/>
-              </a:rPr>
-              <a:t>]</a:t>
-            </a:r>
-            <a:r>
-              <a:rPr lang="en-US" altLang="ko-KR" sz="2800" dirty="0">
-                <a:solidFill>
-                  <a:srgbClr val="212529"/>
-                </a:solidFill>
-                <a:latin typeface="+mn-ea"/>
-              </a:rPr>
-              <a:t> </a:t>
-            </a:r>
-            <a:r>
-              <a:rPr lang="ko-KR" altLang="en-US" sz="2800" dirty="0">
-                <a:solidFill>
-                  <a:srgbClr val="212529"/>
-                </a:solidFill>
-                <a:latin typeface="+mn-ea"/>
-              </a:rPr>
-              <a:t>커리큘럼 클릭</a:t>
-            </a:r>
-            <a:endParaRPr lang="en-US" altLang="ko-KR" sz="2800" dirty="0">
-              <a:solidFill>
-                <a:srgbClr val="212529"/>
-              </a:solidFill>
-              <a:latin typeface="+mn-ea"/>
-            </a:endParaRPr>
-          </a:p>
-          <a:p>
-            <a:pPr lvl="1"/>
-            <a:r>
-              <a:rPr lang="ko-KR" altLang="en-US" sz="2800" b="1" dirty="0">
-                <a:solidFill>
-                  <a:srgbClr val="212529"/>
-                </a:solidFill>
-                <a:latin typeface="+mn-ea"/>
-              </a:rPr>
-              <a:t>➡ </a:t>
-            </a:r>
-            <a:r>
-              <a:rPr lang="en-US" altLang="ko-KR" sz="2800" b="1" dirty="0">
-                <a:solidFill>
-                  <a:schemeClr val="accent1"/>
-                </a:solidFill>
-                <a:latin typeface="+mn-ea"/>
-              </a:rPr>
-              <a:t>[Promise </a:t>
-            </a:r>
-            <a:r>
-              <a:rPr lang="ko-KR" altLang="en-US" sz="2800" b="1" dirty="0">
-                <a:solidFill>
-                  <a:schemeClr val="accent1"/>
-                </a:solidFill>
-                <a:latin typeface="+mn-ea"/>
-              </a:rPr>
-              <a:t>사용하기 </a:t>
-            </a:r>
-            <a:r>
-              <a:rPr lang="en-US" altLang="ko-KR" sz="2800" b="1" dirty="0">
-                <a:solidFill>
-                  <a:schemeClr val="accent1"/>
-                </a:solidFill>
-                <a:latin typeface="+mn-ea"/>
-              </a:rPr>
-              <a:t>(2)]</a:t>
-            </a:r>
-            <a:r>
-              <a:rPr lang="en-US" altLang="ko-KR" sz="2800" dirty="0">
-                <a:solidFill>
-                  <a:schemeClr val="accent1"/>
-                </a:solidFill>
-                <a:latin typeface="+mn-ea"/>
-              </a:rPr>
-              <a:t> </a:t>
-            </a:r>
-            <a:r>
-              <a:rPr lang="ko-KR" altLang="en-US" sz="2800" dirty="0">
-                <a:solidFill>
-                  <a:srgbClr val="212529"/>
-                </a:solidFill>
-                <a:latin typeface="+mn-ea"/>
-              </a:rPr>
-              <a:t> 진행</a:t>
+            <a:r>
+              <a:rPr lang="ko-KR" altLang="en-US" sz="2000" b="1" dirty="0"/>
+              <a:t>🚀 실행 결과</a:t>
             </a:r>
           </a:p>
         </p:txBody>
@@ -31089,7 +31142,7 @@
     </p:spTree>
     <p:extLst>
       <p:ext uri="{BB962C8B-B14F-4D97-AF65-F5344CB8AC3E}">
-        <p14:creationId xmlns:p14="http://schemas.microsoft.com/office/powerpoint/2010/main" val="2181435170"/>
+        <p14:creationId xmlns:p14="http://schemas.microsoft.com/office/powerpoint/2010/main" val="2516166436"/>
       </p:ext>
     </p:extLst>
   </p:cSld>
@@ -31118,10 +31171,136 @@
       </p:grpSpPr>
       <p:sp>
         <p:nvSpPr>
-          <p:cNvPr id="13" name="내용 개체 틀 2">
+          <p:cNvPr id="2" name="제목 1">
             <a:extLst>
               <a:ext uri="{FF2B5EF4-FFF2-40B4-BE49-F238E27FC236}">
-                <a16:creationId xmlns:a16="http://schemas.microsoft.com/office/drawing/2014/main" id="{847FD532-7F61-A001-537F-B970BD821AF3}"/>
+                <a16:creationId xmlns:a16="http://schemas.microsoft.com/office/drawing/2014/main" id="{D1B8A310-1A1F-09FC-4A9E-98188CCD3C40}"/>
+              </a:ext>
+            </a:extLst>
+          </p:cNvPr>
+          <p:cNvSpPr>
+            <a:spLocks noGrp="1"/>
+          </p:cNvSpPr>
+          <p:nvPr>
+            <p:ph type="title"/>
+          </p:nvPr>
+        </p:nvSpPr>
+        <p:spPr/>
+        <p:txBody>
+          <a:bodyPr/>
+          <a:lstStyle/>
+          <a:p>
+            <a:r>
+              <a:rPr lang="ko-KR" altLang="en-US" dirty="0">
+                <a:solidFill>
+                  <a:srgbClr val="ED7D31"/>
+                </a:solidFill>
+              </a:rPr>
+              <a:t>실습</a:t>
+            </a:r>
+            <a:r>
+              <a:rPr lang="en-US" altLang="ko-KR" dirty="0">
+                <a:solidFill>
+                  <a:srgbClr val="ED7D31"/>
+                </a:solidFill>
+              </a:rPr>
+              <a:t>3</a:t>
+            </a:r>
+            <a:r>
+              <a:rPr lang="en-US" altLang="ko-KR" dirty="0">
+                <a:solidFill>
+                  <a:schemeClr val="accent2"/>
+                </a:solidFill>
+              </a:rPr>
+              <a:t>.</a:t>
+            </a:r>
+            <a:r>
+              <a:rPr lang="en-US" altLang="ko-KR" dirty="0"/>
+              <a:t> </a:t>
+            </a:r>
+            <a:r>
+              <a:rPr lang="en-US" altLang="ko-KR" dirty="0">
+                <a:solidFill>
+                  <a:schemeClr val="accent2"/>
+                </a:solidFill>
+              </a:rPr>
+              <a:t>Promise</a:t>
+            </a:r>
+            <a:r>
+              <a:rPr lang="ko-KR" altLang="en-US" dirty="0">
+                <a:solidFill>
+                  <a:schemeClr val="accent2"/>
+                </a:solidFill>
+              </a:rPr>
+              <a:t>로 배경색 변경하기</a:t>
+            </a:r>
+          </a:p>
+        </p:txBody>
+      </p:sp>
+      <p:sp>
+        <p:nvSpPr>
+          <p:cNvPr id="3" name="날짜 개체 틀 2">
+            <a:extLst>
+              <a:ext uri="{FF2B5EF4-FFF2-40B4-BE49-F238E27FC236}">
+                <a16:creationId xmlns:a16="http://schemas.microsoft.com/office/drawing/2014/main" id="{6C33EE99-62C7-4220-ABBA-B056CAC671FC}"/>
+              </a:ext>
+            </a:extLst>
+          </p:cNvPr>
+          <p:cNvSpPr>
+            <a:spLocks noGrp="1"/>
+          </p:cNvSpPr>
+          <p:nvPr>
+            <p:ph type="dt" sz="half" idx="10"/>
+          </p:nvPr>
+        </p:nvSpPr>
+        <p:spPr/>
+        <p:txBody>
+          <a:bodyPr/>
+          <a:lstStyle/>
+          <a:p>
+            <a:fld id="{9E387F8A-5546-492F-8DED-673FD4531098}" type="datetime6">
+              <a:rPr lang="ko-KR" altLang="en-US" smtClean="0"/>
+              <a:t>2026년 2월</a:t>
+            </a:fld>
+            <a:endParaRPr lang="ko-KR" altLang="en-US"/>
+          </a:p>
+        </p:txBody>
+      </p:sp>
+      <p:sp>
+        <p:nvSpPr>
+          <p:cNvPr id="4" name="슬라이드 번호 개체 틀 3">
+            <a:extLst>
+              <a:ext uri="{FF2B5EF4-FFF2-40B4-BE49-F238E27FC236}">
+                <a16:creationId xmlns:a16="http://schemas.microsoft.com/office/drawing/2014/main" id="{F3EFD188-FCCD-74C3-81B0-73381D2D4ADB}"/>
+              </a:ext>
+            </a:extLst>
+          </p:cNvPr>
+          <p:cNvSpPr>
+            <a:spLocks noGrp="1"/>
+          </p:cNvSpPr>
+          <p:nvPr>
+            <p:ph type="sldNum" sz="quarter" idx="12"/>
+          </p:nvPr>
+        </p:nvSpPr>
+        <p:spPr/>
+        <p:txBody>
+          <a:bodyPr/>
+          <a:lstStyle/>
+          <a:p>
+            <a:fld id="{083A2CE0-18CD-4102-B738-4ACFF9E68BA4}" type="slidenum">
+              <a:rPr lang="ko-KR" altLang="en-US" smtClean="0"/>
+              <a:t>52</a:t>
+            </a:fld>
+            <a:endParaRPr lang="ko-KR" altLang="en-US"/>
+          </a:p>
+        </p:txBody>
+      </p:sp>
+      <p:sp>
+        <p:nvSpPr>
+          <p:cNvPr id="5" name="내용 개체 틀 7">
+            <a:extLst>
+              <a:ext uri="{FF2B5EF4-FFF2-40B4-BE49-F238E27FC236}">
+                <a16:creationId xmlns:a16="http://schemas.microsoft.com/office/drawing/2014/main" id="{11487B41-A202-BE61-B09C-97ECDFE989C5}"/>
               </a:ext>
             </a:extLst>
           </p:cNvPr>
@@ -31134,8 +31313,8 @@
         </p:nvSpPr>
         <p:spPr>
           <a:xfrm>
-            <a:off x="510988" y="1328391"/>
-            <a:ext cx="11260802" cy="5328442"/>
+            <a:off x="827313" y="1325563"/>
+            <a:ext cx="10299865" cy="4558228"/>
           </a:xfrm>
         </p:spPr>
         <p:txBody>
@@ -31144,585 +31323,63 @@
           </a:bodyPr>
           <a:lstStyle/>
           <a:p>
-            <a:endParaRPr lang="en-US" altLang="ko-KR" dirty="0"/>
-          </a:p>
-          <a:p>
             <a:pPr marL="0" indent="0">
               <a:buNone/>
             </a:pPr>
-            <a:endParaRPr lang="en-US" altLang="ko-KR" dirty="0"/>
-          </a:p>
-          <a:p>
-            <a:endParaRPr lang="en-US" altLang="ko-KR" dirty="0"/>
-          </a:p>
-        </p:txBody>
-      </p:sp>
-      <p:sp>
-        <p:nvSpPr>
-          <p:cNvPr id="4" name="날짜 개체 틀 3">
+            <a:r>
+              <a:rPr lang="ko-KR" altLang="en-US"/>
+              <a:t>콜백지옥으로 </a:t>
+            </a:r>
+            <a:r>
+              <a:rPr lang="ko-KR" altLang="en-US" dirty="0"/>
+              <a:t>작성한 배경색 변경 코드를 </a:t>
+            </a:r>
+            <a:r>
+              <a:rPr lang="en-US" altLang="ko-KR" dirty="0"/>
+              <a:t>Promise</a:t>
+            </a:r>
+            <a:r>
+              <a:rPr lang="ko-KR" altLang="en-US" dirty="0"/>
+              <a:t>를 이용해 변경하기</a:t>
+            </a:r>
+            <a:endParaRPr lang="en-US" altLang="ko-KR" sz="2000" dirty="0"/>
+          </a:p>
+        </p:txBody>
+      </p:sp>
+      <p:pic>
+        <p:nvPicPr>
+          <p:cNvPr id="11" name="그림 10">
             <a:extLst>
               <a:ext uri="{FF2B5EF4-FFF2-40B4-BE49-F238E27FC236}">
-                <a16:creationId xmlns:a16="http://schemas.microsoft.com/office/drawing/2014/main" id="{A695DDE5-0A39-A366-4CFE-A283911999CD}"/>
+                <a16:creationId xmlns:a16="http://schemas.microsoft.com/office/drawing/2014/main" id="{869DEA6F-F7A7-1FC0-5B4E-14C2FFDE9B03}"/>
               </a:ext>
             </a:extLst>
           </p:cNvPr>
-          <p:cNvSpPr>
-            <a:spLocks noGrp="1"/>
-          </p:cNvSpPr>
-          <p:nvPr>
-            <p:ph type="dt" sz="half" idx="10"/>
-          </p:nvPr>
-        </p:nvSpPr>
-        <p:spPr/>
-        <p:txBody>
-          <a:bodyPr/>
-          <a:lstStyle/>
-          <a:p>
-            <a:fld id="{0F78D9C4-20C1-4B15-A116-16DC77AD9A1E}" type="datetime1">
-              <a:rPr lang="ko-KR" altLang="en-US" smtClean="0"/>
-              <a:t>2026-01-06</a:t>
-            </a:fld>
-            <a:endParaRPr lang="ko-KR" altLang="en-US"/>
-          </a:p>
-        </p:txBody>
-      </p:sp>
-      <p:sp>
-        <p:nvSpPr>
-          <p:cNvPr id="5" name="슬라이드 번호 개체 틀 4">
-            <a:extLst>
-              <a:ext uri="{FF2B5EF4-FFF2-40B4-BE49-F238E27FC236}">
-                <a16:creationId xmlns:a16="http://schemas.microsoft.com/office/drawing/2014/main" id="{5E040F43-60A7-C50D-1F5B-F984054F2D7C}"/>
-              </a:ext>
-            </a:extLst>
-          </p:cNvPr>
-          <p:cNvSpPr>
-            <a:spLocks noGrp="1"/>
-          </p:cNvSpPr>
-          <p:nvPr>
-            <p:ph type="sldNum" sz="quarter" idx="12"/>
-          </p:nvPr>
-        </p:nvSpPr>
-        <p:spPr/>
-        <p:txBody>
-          <a:bodyPr/>
-          <a:lstStyle/>
-          <a:p>
-            <a:fld id="{083A2CE0-18CD-4102-B738-4ACFF9E68BA4}" type="slidenum">
-              <a:rPr lang="ko-KR" altLang="en-US" smtClean="0"/>
-              <a:t>52</a:t>
-            </a:fld>
-            <a:endParaRPr lang="ko-KR" altLang="en-US"/>
-          </a:p>
-        </p:txBody>
-      </p:sp>
-      <p:sp>
-        <p:nvSpPr>
-          <p:cNvPr id="2" name="제목 1">
-            <a:extLst>
-              <a:ext uri="{FF2B5EF4-FFF2-40B4-BE49-F238E27FC236}">
-                <a16:creationId xmlns:a16="http://schemas.microsoft.com/office/drawing/2014/main" id="{5FAC57F5-99D7-9C46-B6C1-D16224151FE9}"/>
-              </a:ext>
-            </a:extLst>
-          </p:cNvPr>
-          <p:cNvSpPr>
-            <a:spLocks noGrp="1"/>
-          </p:cNvSpPr>
-          <p:nvPr>
-            <p:ph type="title"/>
-          </p:nvPr>
-        </p:nvSpPr>
-        <p:spPr/>
-        <p:txBody>
-          <a:bodyPr/>
-          <a:lstStyle/>
-          <a:p>
-            <a:r>
-              <a:rPr lang="ko-KR" altLang="en-US" dirty="0">
-                <a:solidFill>
-                  <a:srgbClr val="ED7D31"/>
-                </a:solidFill>
-              </a:rPr>
-              <a:t>실습</a:t>
-            </a:r>
-            <a:r>
-              <a:rPr lang="en-US" altLang="ko-KR" dirty="0">
-                <a:solidFill>
-                  <a:srgbClr val="ED7D31"/>
-                </a:solidFill>
-              </a:rPr>
-              <a:t>. Promise </a:t>
-            </a:r>
-            <a:r>
-              <a:rPr lang="ko-KR" altLang="en-US" dirty="0">
-                <a:solidFill>
-                  <a:srgbClr val="ED7D31"/>
-                </a:solidFill>
-              </a:rPr>
-              <a:t>사용하기 </a:t>
-            </a:r>
-            <a:r>
-              <a:rPr lang="en-US" altLang="ko-KR" dirty="0">
-                <a:solidFill>
-                  <a:srgbClr val="ED7D31"/>
-                </a:solidFill>
-              </a:rPr>
-              <a:t>(3)</a:t>
-            </a:r>
-            <a:endParaRPr lang="ko-KR" altLang="en-US" dirty="0">
-              <a:solidFill>
-                <a:srgbClr val="ED7D31"/>
-              </a:solidFill>
-            </a:endParaRPr>
-          </a:p>
-        </p:txBody>
-      </p:sp>
-      <p:sp>
-        <p:nvSpPr>
-          <p:cNvPr id="6" name="내용 개체 틀 1">
-            <a:extLst>
-              <a:ext uri="{FF2B5EF4-FFF2-40B4-BE49-F238E27FC236}">
-                <a16:creationId xmlns:a16="http://schemas.microsoft.com/office/drawing/2014/main" id="{70C2BA37-BE91-39C4-AC08-0E8A1052E2F7}"/>
-              </a:ext>
-            </a:extLst>
-          </p:cNvPr>
-          <p:cNvSpPr txBox="1">
-            <a:spLocks/>
-          </p:cNvSpPr>
+          <p:cNvPicPr>
+            <a:picLocks noChangeAspect="1"/>
+          </p:cNvPicPr>
           <p:nvPr/>
-        </p:nvSpPr>
+        </p:nvPicPr>
+        <p:blipFill>
+          <a:blip r:embed="rId3"/>
+          <a:stretch>
+            <a:fillRect/>
+          </a:stretch>
+        </p:blipFill>
         <p:spPr>
           <a:xfrm>
-            <a:off x="838200" y="1825625"/>
-            <a:ext cx="10515600" cy="4351338"/>
+            <a:off x="5509588" y="2072574"/>
+            <a:ext cx="5400150" cy="3811217"/>
           </a:xfrm>
           <a:prstGeom prst="rect">
             <a:avLst/>
           </a:prstGeom>
         </p:spPr>
-        <p:txBody>
-          <a:bodyPr vert="horz" lIns="91440" tIns="45720" rIns="91440" bIns="45720" rtlCol="0">
-            <a:normAutofit/>
-          </a:bodyPr>
-          <a:lstStyle>
-            <a:lvl1pPr marL="228600" indent="-228600" algn="l" defTabSz="914400" rtl="0" eaLnBrk="1" latinLnBrk="1" hangingPunct="1">
-              <a:lnSpc>
-                <a:spcPct val="90000"/>
-              </a:lnSpc>
-              <a:spcBef>
-                <a:spcPts val="1000"/>
-              </a:spcBef>
-              <a:buFont typeface="Arial" panose="020B0604020202020204" pitchFamily="34" charset="0"/>
-              <a:buChar char="•"/>
-              <a:defRPr sz="2800" kern="1200">
-                <a:solidFill>
-                  <a:schemeClr val="tx1"/>
-                </a:solidFill>
-                <a:latin typeface="+mn-lt"/>
-                <a:ea typeface="+mn-ea"/>
-                <a:cs typeface="+mn-cs"/>
-              </a:defRPr>
-            </a:lvl1pPr>
-            <a:lvl2pPr marL="685800" indent="-228600" algn="l" defTabSz="914400" rtl="0" eaLnBrk="1" latinLnBrk="1" hangingPunct="1">
-              <a:lnSpc>
-                <a:spcPct val="90000"/>
-              </a:lnSpc>
-              <a:spcBef>
-                <a:spcPts val="500"/>
-              </a:spcBef>
-              <a:buFont typeface="Arial" panose="020B0604020202020204" pitchFamily="34" charset="0"/>
-              <a:buChar char="•"/>
-              <a:defRPr sz="2400" kern="1200">
-                <a:solidFill>
-                  <a:schemeClr val="tx1"/>
-                </a:solidFill>
-                <a:latin typeface="+mn-lt"/>
-                <a:ea typeface="+mn-ea"/>
-                <a:cs typeface="+mn-cs"/>
-              </a:defRPr>
-            </a:lvl2pPr>
-            <a:lvl3pPr marL="1143000" indent="-228600" algn="l" defTabSz="914400" rtl="0" eaLnBrk="1" latinLnBrk="1" hangingPunct="1">
-              <a:lnSpc>
-                <a:spcPct val="90000"/>
-              </a:lnSpc>
-              <a:spcBef>
-                <a:spcPts val="500"/>
-              </a:spcBef>
-              <a:buFont typeface="Arial" panose="020B0604020202020204" pitchFamily="34" charset="0"/>
-              <a:buChar char="•"/>
-              <a:defRPr sz="2000" kern="1200">
-                <a:solidFill>
-                  <a:schemeClr val="tx1"/>
-                </a:solidFill>
-                <a:latin typeface="+mn-lt"/>
-                <a:ea typeface="+mn-ea"/>
-                <a:cs typeface="+mn-cs"/>
-              </a:defRPr>
-            </a:lvl3pPr>
-            <a:lvl4pPr marL="1600200" indent="-228600" algn="l" defTabSz="914400" rtl="0" eaLnBrk="1" latinLnBrk="1" hangingPunct="1">
-              <a:lnSpc>
-                <a:spcPct val="90000"/>
-              </a:lnSpc>
-              <a:spcBef>
-                <a:spcPts val="500"/>
-              </a:spcBef>
-              <a:buFont typeface="Arial" panose="020B0604020202020204" pitchFamily="34" charset="0"/>
-              <a:buChar char="•"/>
-              <a:defRPr sz="1800" kern="1200">
-                <a:solidFill>
-                  <a:schemeClr val="tx1"/>
-                </a:solidFill>
-                <a:latin typeface="+mn-lt"/>
-                <a:ea typeface="+mn-ea"/>
-                <a:cs typeface="+mn-cs"/>
-              </a:defRPr>
-            </a:lvl4pPr>
-            <a:lvl5pPr marL="2057400" indent="-228600" algn="l" defTabSz="914400" rtl="0" eaLnBrk="1" latinLnBrk="1" hangingPunct="1">
-              <a:lnSpc>
-                <a:spcPct val="90000"/>
-              </a:lnSpc>
-              <a:spcBef>
-                <a:spcPts val="500"/>
-              </a:spcBef>
-              <a:buFont typeface="Arial" panose="020B0604020202020204" pitchFamily="34" charset="0"/>
-              <a:buChar char="•"/>
-              <a:defRPr sz="1800" kern="1200">
-                <a:solidFill>
-                  <a:schemeClr val="tx1"/>
-                </a:solidFill>
-                <a:latin typeface="+mn-lt"/>
-                <a:ea typeface="+mn-ea"/>
-                <a:cs typeface="+mn-cs"/>
-              </a:defRPr>
-            </a:lvl5pPr>
-            <a:lvl6pPr marL="2514600" indent="-228600" algn="l" defTabSz="914400" rtl="0" eaLnBrk="1" latinLnBrk="1" hangingPunct="1">
-              <a:lnSpc>
-                <a:spcPct val="90000"/>
-              </a:lnSpc>
-              <a:spcBef>
-                <a:spcPts val="500"/>
-              </a:spcBef>
-              <a:buFont typeface="Arial" panose="020B0604020202020204" pitchFamily="34" charset="0"/>
-              <a:buChar char="•"/>
-              <a:defRPr sz="1800" kern="1200">
-                <a:solidFill>
-                  <a:schemeClr val="tx1"/>
-                </a:solidFill>
-                <a:latin typeface="+mn-lt"/>
-                <a:ea typeface="+mn-ea"/>
-                <a:cs typeface="+mn-cs"/>
-              </a:defRPr>
-            </a:lvl6pPr>
-            <a:lvl7pPr marL="2971800" indent="-228600" algn="l" defTabSz="914400" rtl="0" eaLnBrk="1" latinLnBrk="1" hangingPunct="1">
-              <a:lnSpc>
-                <a:spcPct val="90000"/>
-              </a:lnSpc>
-              <a:spcBef>
-                <a:spcPts val="500"/>
-              </a:spcBef>
-              <a:buFont typeface="Arial" panose="020B0604020202020204" pitchFamily="34" charset="0"/>
-              <a:buChar char="•"/>
-              <a:defRPr sz="1800" kern="1200">
-                <a:solidFill>
-                  <a:schemeClr val="tx1"/>
-                </a:solidFill>
-                <a:latin typeface="+mn-lt"/>
-                <a:ea typeface="+mn-ea"/>
-                <a:cs typeface="+mn-cs"/>
-              </a:defRPr>
-            </a:lvl7pPr>
-            <a:lvl8pPr marL="3429000" indent="-228600" algn="l" defTabSz="914400" rtl="0" eaLnBrk="1" latinLnBrk="1" hangingPunct="1">
-              <a:lnSpc>
-                <a:spcPct val="90000"/>
-              </a:lnSpc>
-              <a:spcBef>
-                <a:spcPts val="500"/>
-              </a:spcBef>
-              <a:buFont typeface="Arial" panose="020B0604020202020204" pitchFamily="34" charset="0"/>
-              <a:buChar char="•"/>
-              <a:defRPr sz="1800" kern="1200">
-                <a:solidFill>
-                  <a:schemeClr val="tx1"/>
-                </a:solidFill>
-                <a:latin typeface="+mn-lt"/>
-                <a:ea typeface="+mn-ea"/>
-                <a:cs typeface="+mn-cs"/>
-              </a:defRPr>
-            </a:lvl8pPr>
-            <a:lvl9pPr marL="3886200" indent="-228600" algn="l" defTabSz="914400" rtl="0" eaLnBrk="1" latinLnBrk="1" hangingPunct="1">
-              <a:lnSpc>
-                <a:spcPct val="90000"/>
-              </a:lnSpc>
-              <a:spcBef>
-                <a:spcPts val="500"/>
-              </a:spcBef>
-              <a:buFont typeface="Arial" panose="020B0604020202020204" pitchFamily="34" charset="0"/>
-              <a:buChar char="•"/>
-              <a:defRPr sz="1800" kern="1200">
-                <a:solidFill>
-                  <a:schemeClr val="tx1"/>
-                </a:solidFill>
-                <a:latin typeface="+mn-lt"/>
-                <a:ea typeface="+mn-ea"/>
-                <a:cs typeface="+mn-cs"/>
-              </a:defRPr>
-            </a:lvl9pPr>
-          </a:lstStyle>
-          <a:p>
-            <a:pPr marL="457200" lvl="1" indent="0">
-              <a:buFont typeface="Arial" panose="020B0604020202020204" pitchFamily="34" charset="0"/>
-              <a:buNone/>
-            </a:pPr>
-            <a:endParaRPr lang="en-US" altLang="ko-KR" dirty="0">
-              <a:solidFill>
-                <a:srgbClr val="212529"/>
-              </a:solidFill>
-              <a:latin typeface="+mn-ea"/>
-            </a:endParaRPr>
-          </a:p>
-          <a:p>
-            <a:pPr marL="457200" lvl="1" indent="0">
-              <a:buFont typeface="Arial" panose="020B0604020202020204" pitchFamily="34" charset="0"/>
-              <a:buNone/>
-            </a:pPr>
-            <a:endParaRPr lang="en-US" altLang="ko-KR" dirty="0">
-              <a:solidFill>
-                <a:srgbClr val="212529"/>
-              </a:solidFill>
-              <a:latin typeface="+mn-ea"/>
-            </a:endParaRPr>
-          </a:p>
-          <a:p>
-            <a:r>
-              <a:rPr lang="en-US" altLang="ko-KR" b="1" dirty="0">
-                <a:solidFill>
-                  <a:srgbClr val="212529"/>
-                </a:solidFill>
-                <a:latin typeface="+mn-ea"/>
-              </a:rPr>
-              <a:t>[</a:t>
-            </a:r>
-            <a:r>
-              <a:rPr lang="ko-KR" altLang="en-US" b="1" dirty="0" err="1">
-                <a:solidFill>
-                  <a:srgbClr val="212529"/>
-                </a:solidFill>
-                <a:latin typeface="+mn-ea"/>
-              </a:rPr>
-              <a:t>코딩온</a:t>
-            </a:r>
-            <a:r>
-              <a:rPr lang="en-US" altLang="ko-KR" b="1" dirty="0">
-                <a:solidFill>
-                  <a:srgbClr val="212529"/>
-                </a:solidFill>
-                <a:latin typeface="+mn-ea"/>
-              </a:rPr>
-              <a:t>] Node.js </a:t>
-            </a:r>
-            <a:r>
-              <a:rPr lang="ko-KR" altLang="en-US" b="1" dirty="0">
-                <a:solidFill>
-                  <a:srgbClr val="212529"/>
-                </a:solidFill>
-                <a:latin typeface="+mn-ea"/>
-              </a:rPr>
-              <a:t>실습</a:t>
-            </a:r>
-            <a:r>
-              <a:rPr lang="en-US" altLang="ko-KR" b="1" dirty="0">
-                <a:solidFill>
-                  <a:srgbClr val="212529"/>
-                </a:solidFill>
-                <a:latin typeface="+mn-ea"/>
-              </a:rPr>
-              <a:t> </a:t>
-            </a:r>
-            <a:r>
-              <a:rPr lang="ko-KR" altLang="en-US" dirty="0">
-                <a:solidFill>
-                  <a:srgbClr val="212529"/>
-                </a:solidFill>
-                <a:latin typeface="+mn-ea"/>
-              </a:rPr>
-              <a:t>강의 클릭</a:t>
-            </a:r>
-            <a:br>
-              <a:rPr lang="en-US" altLang="ko-KR" dirty="0">
-                <a:solidFill>
-                  <a:srgbClr val="212529"/>
-                </a:solidFill>
-                <a:latin typeface="+mn-ea"/>
-              </a:rPr>
-            </a:br>
-            <a:endParaRPr lang="en-US" altLang="ko-KR" dirty="0">
-              <a:solidFill>
-                <a:srgbClr val="212529"/>
-              </a:solidFill>
-              <a:latin typeface="+mn-ea"/>
-            </a:endParaRPr>
-          </a:p>
-          <a:p>
-            <a:pPr lvl="1"/>
-            <a:r>
-              <a:rPr lang="ko-KR" altLang="en-US" sz="2800" b="1" dirty="0">
-                <a:solidFill>
-                  <a:srgbClr val="212529"/>
-                </a:solidFill>
-                <a:latin typeface="+mn-ea"/>
-              </a:rPr>
-              <a:t>➡ </a:t>
-            </a:r>
-            <a:r>
-              <a:rPr lang="en-US" altLang="ko-KR" sz="2800" b="1" dirty="0">
-                <a:solidFill>
-                  <a:srgbClr val="212529"/>
-                </a:solidFill>
-                <a:latin typeface="+mn-ea"/>
-              </a:rPr>
-              <a:t>[Async</a:t>
-            </a:r>
-            <a:r>
-              <a:rPr lang="ko-KR" altLang="en-US" sz="2800" b="1" dirty="0">
-                <a:solidFill>
-                  <a:srgbClr val="212529"/>
-                </a:solidFill>
-                <a:latin typeface="+mn-ea"/>
-              </a:rPr>
-              <a:t> </a:t>
-            </a:r>
-            <a:r>
-              <a:rPr lang="en-US" altLang="ko-KR" sz="2800" b="1" dirty="0">
-                <a:solidFill>
-                  <a:srgbClr val="212529"/>
-                </a:solidFill>
-                <a:latin typeface="+mn-ea"/>
-              </a:rPr>
-              <a:t>/</a:t>
-            </a:r>
-            <a:r>
-              <a:rPr lang="ko-KR" altLang="en-US" sz="2800" b="1" dirty="0">
-                <a:solidFill>
-                  <a:srgbClr val="212529"/>
-                </a:solidFill>
-                <a:latin typeface="+mn-ea"/>
-              </a:rPr>
-              <a:t> </a:t>
-            </a:r>
-            <a:r>
-              <a:rPr lang="en-US" altLang="ko-KR" sz="2800" b="1" dirty="0">
-                <a:solidFill>
-                  <a:srgbClr val="212529"/>
-                </a:solidFill>
-                <a:latin typeface="+mn-ea"/>
-              </a:rPr>
-              <a:t>Await</a:t>
-            </a:r>
-            <a:r>
-              <a:rPr lang="ko-KR" altLang="en-US" sz="2800" b="1" dirty="0">
-                <a:solidFill>
-                  <a:srgbClr val="212529"/>
-                </a:solidFill>
-                <a:latin typeface="+mn-ea"/>
-              </a:rPr>
-              <a:t> 실습</a:t>
-            </a:r>
-            <a:r>
-              <a:rPr lang="en-US" altLang="ko-KR" sz="2800" b="1" dirty="0">
-                <a:solidFill>
-                  <a:srgbClr val="212529"/>
-                </a:solidFill>
-                <a:latin typeface="+mn-ea"/>
-              </a:rPr>
-              <a:t>]</a:t>
-            </a:r>
-            <a:r>
-              <a:rPr lang="en-US" altLang="ko-KR" sz="2800" dirty="0">
-                <a:solidFill>
-                  <a:srgbClr val="212529"/>
-                </a:solidFill>
-                <a:latin typeface="+mn-ea"/>
-              </a:rPr>
-              <a:t> </a:t>
-            </a:r>
-            <a:r>
-              <a:rPr lang="ko-KR" altLang="en-US" sz="2800" dirty="0">
-                <a:solidFill>
-                  <a:srgbClr val="212529"/>
-                </a:solidFill>
-                <a:latin typeface="+mn-ea"/>
-              </a:rPr>
-              <a:t>커리큘럼 클릭</a:t>
-            </a:r>
-            <a:endParaRPr lang="en-US" altLang="ko-KR" sz="2800" dirty="0">
-              <a:solidFill>
-                <a:srgbClr val="212529"/>
-              </a:solidFill>
-              <a:latin typeface="+mn-ea"/>
-            </a:endParaRPr>
-          </a:p>
-          <a:p>
-            <a:pPr lvl="1"/>
-            <a:r>
-              <a:rPr lang="ko-KR" altLang="en-US" sz="2800" b="1" dirty="0">
-                <a:solidFill>
-                  <a:srgbClr val="212529"/>
-                </a:solidFill>
-                <a:latin typeface="+mn-ea"/>
-              </a:rPr>
-              <a:t>➡ </a:t>
-            </a:r>
-            <a:r>
-              <a:rPr lang="en-US" altLang="ko-KR" sz="2800" b="1" dirty="0">
-                <a:solidFill>
-                  <a:schemeClr val="accent1"/>
-                </a:solidFill>
-                <a:latin typeface="+mn-ea"/>
-              </a:rPr>
-              <a:t>[Promise </a:t>
-            </a:r>
-            <a:r>
-              <a:rPr lang="ko-KR" altLang="en-US" sz="2800" b="1" dirty="0">
-                <a:solidFill>
-                  <a:schemeClr val="accent1"/>
-                </a:solidFill>
-                <a:latin typeface="+mn-ea"/>
-              </a:rPr>
-              <a:t>사용하기 </a:t>
-            </a:r>
-            <a:r>
-              <a:rPr lang="en-US" altLang="ko-KR" sz="2800" b="1" dirty="0">
-                <a:solidFill>
-                  <a:schemeClr val="accent1"/>
-                </a:solidFill>
-                <a:latin typeface="+mn-ea"/>
-              </a:rPr>
-              <a:t>(3)]</a:t>
-            </a:r>
-            <a:r>
-              <a:rPr lang="en-US" altLang="ko-KR" sz="2800" dirty="0">
-                <a:solidFill>
-                  <a:schemeClr val="accent1"/>
-                </a:solidFill>
-                <a:latin typeface="+mn-ea"/>
-              </a:rPr>
-              <a:t> </a:t>
-            </a:r>
-            <a:r>
-              <a:rPr lang="ko-KR" altLang="en-US" sz="2800" dirty="0">
-                <a:solidFill>
-                  <a:srgbClr val="212529"/>
-                </a:solidFill>
-                <a:latin typeface="+mn-ea"/>
-              </a:rPr>
-              <a:t> 진행</a:t>
-            </a:r>
-          </a:p>
-        </p:txBody>
-      </p:sp>
+      </p:pic>
     </p:spTree>
     <p:extLst>
       <p:ext uri="{BB962C8B-B14F-4D97-AF65-F5344CB8AC3E}">
-        <p14:creationId xmlns:p14="http://schemas.microsoft.com/office/powerpoint/2010/main" val="409428744"/>
+        <p14:creationId xmlns:p14="http://schemas.microsoft.com/office/powerpoint/2010/main" val="987816967"/>
       </p:ext>
     </p:extLst>
   </p:cSld>
@@ -33052,7 +32709,7 @@
           <a:p>
             <a:fld id="{0F78D9C4-20C1-4B15-A116-16DC77AD9A1E}" type="datetime1">
               <a:rPr lang="ko-KR" altLang="en-US" smtClean="0"/>
-              <a:t>2026-01-06</a:t>
+              <a:t>2026-02-02</a:t>
             </a:fld>
             <a:endParaRPr lang="ko-KR" altLang="en-US"/>
           </a:p>
@@ -33350,7 +33007,7 @@
           <a:p>
             <a:fld id="{0F78D9C4-20C1-4B15-A116-16DC77AD9A1E}" type="datetime1">
               <a:rPr lang="ko-KR" altLang="en-US" smtClean="0"/>
-              <a:t>2026-01-06</a:t>
+              <a:t>2026-02-02</a:t>
             </a:fld>
             <a:endParaRPr lang="ko-KR" altLang="en-US"/>
           </a:p>

</xml_diff>

<commit_message>
add react 수업 코드
</commit_message>
<xml_diff>
--- a/material/4_WEB/03_Javascript(2).pptx
+++ b/material/4_WEB/03_Javascript(2).pptx
@@ -270,7 +270,7 @@
             <a:fld id="{A13A867C-D490-40C2-AB8D-A60FA70A9BF5}" type="datetimeFigureOut">
               <a:rPr lang="ko-KR" altLang="en-US" smtClean="0"/>
               <a:pPr/>
-              <a:t>2026-02-02</a:t>
+              <a:t>2026-02-03</a:t>
             </a:fld>
             <a:endParaRPr lang="ko-KR" altLang="en-US" dirty="0"/>
           </a:p>
@@ -5210,7 +5210,7 @@
           <a:p>
             <a:fld id="{442BEE3F-2E9A-4FD8-8B8A-8619F3E161C0}" type="datetime1">
               <a:rPr lang="ko-KR" altLang="en-US" smtClean="0"/>
-              <a:t>2026-02-02</a:t>
+              <a:t>2026-02-03</a:t>
             </a:fld>
             <a:endParaRPr lang="ko-KR" altLang="en-US"/>
           </a:p>
@@ -5497,7 +5497,7 @@
           <a:p>
             <a:fld id="{0F78D9C4-20C1-4B15-A116-16DC77AD9A1E}" type="datetime1">
               <a:rPr lang="ko-KR" altLang="en-US" smtClean="0"/>
-              <a:t>2026-02-02</a:t>
+              <a:t>2026-02-03</a:t>
             </a:fld>
             <a:endParaRPr lang="ko-KR" altLang="en-US"/>
           </a:p>
@@ -5672,7 +5672,7 @@
           <a:p>
             <a:fld id="{7F5E23C3-0E3D-4E4E-8486-D7FB4C073DC1}" type="datetime1">
               <a:rPr lang="ko-KR" altLang="en-US" smtClean="0"/>
-              <a:t>2026-02-02</a:t>
+              <a:t>2026-02-03</a:t>
             </a:fld>
             <a:endParaRPr lang="ko-KR" altLang="en-US"/>
           </a:p>
@@ -6206,7 +6206,7 @@
           <a:p>
             <a:fld id="{7F5E23C3-0E3D-4E4E-8486-D7FB4C073DC1}" type="datetime1">
               <a:rPr lang="ko-KR" altLang="en-US" smtClean="0"/>
-              <a:t>2026-02-02</a:t>
+              <a:t>2026-02-03</a:t>
             </a:fld>
             <a:endParaRPr lang="ko-KR" altLang="en-US"/>
           </a:p>
@@ -7169,7 +7169,7 @@
           <a:p>
             <a:fld id="{0F78D9C4-20C1-4B15-A116-16DC77AD9A1E}" type="datetime1">
               <a:rPr lang="ko-KR" altLang="en-US" smtClean="0"/>
-              <a:t>2026-02-02</a:t>
+              <a:t>2026-02-03</a:t>
             </a:fld>
             <a:endParaRPr lang="ko-KR" altLang="en-US"/>
           </a:p>
@@ -7902,7 +7902,7 @@
           <a:p>
             <a:fld id="{0F78D9C4-20C1-4B15-A116-16DC77AD9A1E}" type="datetime1">
               <a:rPr lang="ko-KR" altLang="en-US" smtClean="0"/>
-              <a:t>2026-02-02</a:t>
+              <a:t>2026-02-03</a:t>
             </a:fld>
             <a:endParaRPr lang="ko-KR" altLang="en-US"/>
           </a:p>
@@ -9183,7 +9183,7 @@
           <a:p>
             <a:fld id="{0F78D9C4-20C1-4B15-A116-16DC77AD9A1E}" type="datetime1">
               <a:rPr lang="ko-KR" altLang="en-US" smtClean="0"/>
-              <a:t>2026-02-02</a:t>
+              <a:t>2026-02-03</a:t>
             </a:fld>
             <a:endParaRPr lang="ko-KR" altLang="en-US"/>
           </a:p>
@@ -9625,7 +9625,7 @@
           <a:p>
             <a:fld id="{0F78D9C4-20C1-4B15-A116-16DC77AD9A1E}" type="datetime1">
               <a:rPr lang="ko-KR" altLang="en-US" smtClean="0"/>
-              <a:t>2026-02-02</a:t>
+              <a:t>2026-02-03</a:t>
             </a:fld>
             <a:endParaRPr lang="ko-KR" altLang="en-US"/>
           </a:p>
@@ -9783,7 +9783,7 @@
           <a:p>
             <a:fld id="{0F78D9C4-20C1-4B15-A116-16DC77AD9A1E}" type="datetime1">
               <a:rPr lang="ko-KR" altLang="en-US" smtClean="0"/>
-              <a:t>2026-02-02</a:t>
+              <a:t>2026-02-03</a:t>
             </a:fld>
             <a:endParaRPr lang="ko-KR" altLang="en-US"/>
           </a:p>
@@ -22860,7 +22860,7 @@
         </p:nvSpPr>
         <p:spPr>
           <a:xfrm>
-            <a:off x="1400174" y="3965006"/>
+            <a:off x="2540817" y="3899018"/>
             <a:ext cx="1018903" cy="297818"/>
           </a:xfrm>
           <a:prstGeom prst="rect">
@@ -22914,7 +22914,7 @@
         </p:nvSpPr>
         <p:spPr>
           <a:xfrm>
-            <a:off x="7906733" y="5645761"/>
+            <a:off x="7715753" y="5630306"/>
             <a:ext cx="1018903" cy="297818"/>
           </a:xfrm>
           <a:prstGeom prst="rect">
@@ -23331,7 +23331,7 @@
           <a:p>
             <a:fld id="{0F78D9C4-20C1-4B15-A116-16DC77AD9A1E}" type="datetime1">
               <a:rPr lang="ko-KR" altLang="en-US" smtClean="0"/>
-              <a:t>2026-02-02</a:t>
+              <a:t>2026-02-03</a:t>
             </a:fld>
             <a:endParaRPr lang="ko-KR" altLang="en-US"/>
           </a:p>
@@ -28416,7 +28416,7 @@
           <a:p>
             <a:fld id="{0F78D9C4-20C1-4B15-A116-16DC77AD9A1E}" type="datetime1">
               <a:rPr lang="ko-KR" altLang="en-US" smtClean="0"/>
-              <a:t>2026-02-02</a:t>
+              <a:t>2026-02-03</a:t>
             </a:fld>
             <a:endParaRPr lang="ko-KR" altLang="en-US"/>
           </a:p>
@@ -29842,7 +29842,7 @@
           <a:p>
             <a:fld id="{0F78D9C4-20C1-4B15-A116-16DC77AD9A1E}" type="datetime1">
               <a:rPr lang="ko-KR" altLang="en-US" smtClean="0"/>
-              <a:t>2026-02-02</a:t>
+              <a:t>2026-02-03</a:t>
             </a:fld>
             <a:endParaRPr lang="ko-KR" altLang="en-US"/>
           </a:p>
@@ -32709,7 +32709,7 @@
           <a:p>
             <a:fld id="{0F78D9C4-20C1-4B15-A116-16DC77AD9A1E}" type="datetime1">
               <a:rPr lang="ko-KR" altLang="en-US" smtClean="0"/>
-              <a:t>2026-02-02</a:t>
+              <a:t>2026-02-03</a:t>
             </a:fld>
             <a:endParaRPr lang="ko-KR" altLang="en-US"/>
           </a:p>
@@ -33007,7 +33007,7 @@
           <a:p>
             <a:fld id="{0F78D9C4-20C1-4B15-A116-16DC77AD9A1E}" type="datetime1">
               <a:rPr lang="ko-KR" altLang="en-US" smtClean="0"/>
-              <a:t>2026-02-02</a:t>
+              <a:t>2026-02-03</a:t>
             </a:fld>
             <a:endParaRPr lang="ko-KR" altLang="en-US"/>
           </a:p>

</xml_diff>